<commit_message>
Update backend services, extraction logic, and documentation
</commit_message>
<xml_diff>
--- a/TenderAI_Pitch_Deck.pptx
+++ b/TenderAI_Pitch_Deck.pptx
@@ -2730,7 +2730,7 @@
               <a:buNone/>
             </a:pPr>
             <a:r>
-              <a:rPr lang="en-US" sz="1100" b="1" spc="150" kern="0" dirty="0">
+              <a:rPr lang="en-US" sz="1000" b="1" spc="150" kern="0" dirty="0">
                 <a:solidFill>
                   <a:srgbClr val="00E5A0"/>
                 </a:solidFill>
@@ -2738,9 +2738,9 @@
                 <a:ea typeface="Calibri" pitchFamily="34" charset="-122"/>
                 <a:cs typeface="Calibri" pitchFamily="34" charset="-120"/>
               </a:rPr>
-              <a:t>FRONTEND · React 18 + Vite (Vercel)    BACKEND · FastAPI + Uvicorn (Render)    AUTH · Local · admin / crpf@2025</a:t>
-            </a:r>
-            <a:endParaRPr lang="en-US" sz="1100" dirty="0"/>
+              <a:t>AI · Llama-3.3 70B (Groq) + Sentence-Embeddings + Rules    FRONTEND · React (Vercel)    BACKEND · FastAPI (Render)    DEMO · admin / crpf@2025</a:t>
+            </a:r>
+            <a:endParaRPr lang="en-US" sz="1000" dirty="0"/>
           </a:p>
         </p:txBody>
       </p:sp>
@@ -6757,7 +6757,7 @@
               <a:buNone/>
             </a:pPr>
             <a:r>
-              <a:rPr lang="en-US" sz="1200" dirty="0">
+              <a:rPr lang="en-US" sz="1150" dirty="0">
                 <a:solidFill>
                   <a:srgbClr val="E8ECF4"/>
                 </a:solidFill>
@@ -6767,7 +6767,7 @@
               </a:rPr>
               <a:t>PyMuPDF · Tesseract · python-docx (multi-OCR)</a:t>
             </a:r>
-            <a:endParaRPr lang="en-US" sz="1200" dirty="0"/>
+            <a:endParaRPr lang="en-US" sz="1150" dirty="0"/>
           </a:p>
         </p:txBody>
       </p:sp>
@@ -6816,7 +6816,7 @@
               <a:buNone/>
             </a:pPr>
             <a:r>
-              <a:rPr lang="en-US" sz="1200" dirty="0">
+              <a:rPr lang="en-US" sz="1150" dirty="0">
                 <a:solidFill>
                   <a:srgbClr val="E8ECF4"/>
                 </a:solidFill>
@@ -6824,9 +6824,9 @@
                 <a:ea typeface="Calibri Light" pitchFamily="34" charset="-122"/>
                 <a:cs typeface="Calibri Light" pitchFamily="34" charset="-120"/>
               </a:rPr>
-              <a:t>Regex + section detection extractors</a:t>
-            </a:r>
-            <a:endParaRPr lang="en-US" sz="1200" dirty="0"/>
+              <a:t>🧠 Groq · Llama-3.3 70B (LLM extraction)</a:t>
+            </a:r>
+            <a:endParaRPr lang="en-US" sz="1150" dirty="0"/>
           </a:p>
         </p:txBody>
       </p:sp>
@@ -6875,7 +6875,7 @@
               <a:buNone/>
             </a:pPr>
             <a:r>
-              <a:rPr lang="en-US" sz="1200" dirty="0">
+              <a:rPr lang="en-US" sz="1150" dirty="0">
                 <a:solidFill>
                   <a:srgbClr val="E8ECF4"/>
                 </a:solidFill>
@@ -6883,9 +6883,9 @@
                 <a:ea typeface="Calibri Light" pitchFamily="34" charset="-122"/>
                 <a:cs typeface="Calibri Light" pitchFamily="34" charset="-120"/>
               </a:rPr>
-              <a:t>Confidence scorer (40% OCR · 60% extraction)</a:t>
-            </a:r>
-            <a:endParaRPr lang="en-US" sz="1200" dirty="0"/>
+              <a:t>🧬 sentence-transformers · all-MiniLM-L6-v2</a:t>
+            </a:r>
+            <a:endParaRPr lang="en-US" sz="1150" dirty="0"/>
           </a:p>
         </p:txBody>
       </p:sp>
@@ -6934,7 +6934,7 @@
               <a:buNone/>
             </a:pPr>
             <a:r>
-              <a:rPr lang="en-US" sz="1200" dirty="0">
+              <a:rPr lang="en-US" sz="1150" dirty="0">
                 <a:solidFill>
                   <a:srgbClr val="E8ECF4"/>
                 </a:solidFill>
@@ -6942,9 +6942,9 @@
                 <a:ea typeface="Calibri Light" pitchFamily="34" charset="-122"/>
                 <a:cs typeface="Calibri Light" pitchFamily="34" charset="-120"/>
               </a:rPr>
-              <a:t>Rule-based matching engine — fully deterministic</a:t>
-            </a:r>
-            <a:endParaRPr lang="en-US" sz="1200" dirty="0"/>
+              <a:t>Confidence scorer (40% OCR · 60% extraction)</a:t>
+            </a:r>
+            <a:endParaRPr lang="en-US" sz="1150" dirty="0"/>
           </a:p>
         </p:txBody>
       </p:sp>
@@ -6993,7 +6993,7 @@
               <a:buNone/>
             </a:pPr>
             <a:r>
-              <a:rPr lang="en-US" sz="1200" dirty="0">
+              <a:rPr lang="en-US" sz="1150" dirty="0">
                 <a:solidFill>
                   <a:srgbClr val="E8ECF4"/>
                 </a:solidFill>
@@ -7001,9 +7001,9 @@
                 <a:ea typeface="Calibri Light" pitchFamily="34" charset="-122"/>
                 <a:cs typeface="Calibri Light" pitchFamily="34" charset="-120"/>
               </a:rPr>
-              <a:t>ReportLab PDF + JSON evaluation reports</a:t>
-            </a:r>
-            <a:endParaRPr lang="en-US" sz="1200" dirty="0"/>
+              <a:t>Deterministic rule engine — auditable verdicts</a:t>
+            </a:r>
+            <a:endParaRPr lang="en-US" sz="1150" dirty="0"/>
           </a:p>
         </p:txBody>
       </p:sp>
@@ -7052,7 +7052,7 @@
               <a:buNone/>
             </a:pPr>
             <a:r>
-              <a:rPr lang="en-US" sz="1200" dirty="0">
+              <a:rPr lang="en-US" sz="1150" dirty="0">
                 <a:solidFill>
                   <a:srgbClr val="E8ECF4"/>
                 </a:solidFill>
@@ -7060,9 +7060,9 @@
                 <a:ea typeface="Calibri Light" pitchFamily="34" charset="-122"/>
                 <a:cs typeface="Calibri Light" pitchFamily="34" charset="-120"/>
               </a:rPr>
-              <a:t>Append-only JSONL audit log</a:t>
-            </a:r>
-            <a:endParaRPr lang="en-US" sz="1200" dirty="0"/>
+              <a:t>ReportLab PDF + JSON · append-only audit log</a:t>
+            </a:r>
+            <a:endParaRPr lang="en-US" sz="1150" dirty="0"/>
           </a:p>
         </p:txBody>
       </p:sp>
@@ -9550,7 +9550,7 @@
                 <a:ea typeface="Calibri Light" pitchFamily="34" charset="-122"/>
                 <a:cs typeface="Calibri Light" pitchFamily="34" charset="-120"/>
               </a:rPr>
-              <a:t>Multi-strategy OCR · Indian-system parser · auto-routed NEED_REVIEW · AI Risk Radar · live dashboards.</a:t>
+              <a:t>3-layer hybrid AI: Llama-3.3 70B (Groq) for extraction · sentence-embedding semantic match · deterministic rule engine · AI Risk Radar.</a:t>
             </a:r>
             <a:endParaRPr lang="en-US" sz="1050" dirty="0"/>
           </a:p>
@@ -9716,7 +9716,7 @@
                 <a:ea typeface="Calibri Light" pitchFamily="34" charset="-122"/>
                 <a:cs typeface="Calibri Light" pitchFamily="34" charset="-120"/>
               </a:rPr>
-              <a:t>Zero 3rd-party AI calls · audit log · JSON+PDF sign-off reports · Vercel+Render free-tier deploy.</a:t>
+              <a:t>OCR + rules run inside your container · audit log · JSON+PDF sign-off reports · Vercel + Render production deploy today.</a:t>
             </a:r>
             <a:endParaRPr lang="en-US" sz="1050" dirty="0"/>
           </a:p>
@@ -10048,7 +10048,7 @@
                 <a:ea typeface="Calibri Light" pitchFamily="34" charset="-122"/>
                 <a:cs typeface="Calibri Light" pitchFamily="34" charset="-120"/>
               </a:rPr>
-              <a:t>Stateless container · multi-tenant ready · time-saved metric aggregates · roadmap to LLM second-pass + DSC.</a:t>
+              <a:t>Stateless container · multi-tenant ready · time-saved metric aggregates · roadmap to govt-DB + DSC sign-off.</a:t>
             </a:r>
             <a:endParaRPr lang="en-US" sz="1050" dirty="0"/>
           </a:p>
@@ -19372,7 +19372,7 @@
                 <a:ea typeface="Calibri" pitchFamily="34" charset="-122"/>
                 <a:cs typeface="Calibri" pitchFamily="34" charset="-120"/>
               </a:rPr>
-              <a:t>06 · THE AI PIPELINE</a:t>
+              <a:t>06 · THE HYBRID AI STACK</a:t>
             </a:r>
             <a:endParaRPr lang="en-US" sz="1100" dirty="0"/>
           </a:p>
@@ -19411,7 +19411,7 @@
                 <a:ea typeface="Calibri" pitchFamily="34" charset="-122"/>
                 <a:cs typeface="Calibri" pitchFamily="34" charset="-120"/>
               </a:rPr>
-              <a:t>From raw PDF to signed verdict, in 13 deterministic steps.</a:t>
+              <a:t>Three layers of AI · zero hallucinated verdicts.</a:t>
             </a:r>
             <a:endParaRPr lang="en-US" sz="3000" dirty="0"/>
           </a:p>
@@ -19536,7 +19536,7 @@
                 <a:ea typeface="Calibri" pitchFamily="34" charset="-122"/>
                 <a:cs typeface="Calibri" pitchFamily="34" charset="-120"/>
               </a:rPr>
-              <a:t>INGEST</a:t>
+              <a:t>OCR</a:t>
             </a:r>
             <a:endParaRPr lang="en-US" sz="1400" dirty="0"/>
           </a:p>
@@ -19567,7 +19567,7 @@
               <a:buNone/>
             </a:pPr>
             <a:r>
-              <a:rPr lang="en-US" sz="1200" dirty="0">
+              <a:rPr lang="en-US" sz="1100" dirty="0">
                 <a:solidFill>
                   <a:srgbClr val="8A9ABB"/>
                 </a:solidFill>
@@ -19575,9 +19575,9 @@
                 <a:ea typeface="Calibri Light" pitchFamily="34" charset="-122"/>
                 <a:cs typeface="Calibri Light" pitchFamily="34" charset="-120"/>
               </a:rPr>
-              <a:t>PyMuPDF · Tesseract · DOCX</a:t>
-            </a:r>
-            <a:endParaRPr lang="en-US" sz="1200" dirty="0"/>
+              <a:t>PyMuPDF + Tesseract + python-docx</a:t>
+            </a:r>
+            <a:endParaRPr lang="en-US" sz="1100" dirty="0"/>
           </a:p>
         </p:txBody>
       </p:sp>
@@ -19700,7 +19700,7 @@
                 <a:ea typeface="Calibri" pitchFamily="34" charset="-122"/>
                 <a:cs typeface="Calibri" pitchFamily="34" charset="-120"/>
               </a:rPr>
-              <a:t>🔍</a:t>
+              <a:t>🧠</a:t>
             </a:r>
             <a:endParaRPr lang="en-US" sz="2520" dirty="0"/>
           </a:p>
@@ -19739,7 +19739,7 @@
                 <a:ea typeface="Calibri" pitchFamily="34" charset="-122"/>
                 <a:cs typeface="Calibri" pitchFamily="34" charset="-120"/>
               </a:rPr>
-              <a:t>EXTRACT</a:t>
+              <a:t>LLM</a:t>
             </a:r>
             <a:endParaRPr lang="en-US" sz="1400" dirty="0"/>
           </a:p>
@@ -19770,7 +19770,7 @@
               <a:buNone/>
             </a:pPr>
             <a:r>
-              <a:rPr lang="en-US" sz="1200" dirty="0">
+              <a:rPr lang="en-US" sz="1100" dirty="0">
                 <a:solidFill>
                   <a:srgbClr val="8A9ABB"/>
                 </a:solidFill>
@@ -19778,9 +19778,9 @@
                 <a:ea typeface="Calibri Light" pitchFamily="34" charset="-122"/>
                 <a:cs typeface="Calibri Light" pitchFamily="34" charset="-120"/>
               </a:rPr>
-              <a:t>Regex + section detection</a:t>
-            </a:r>
-            <a:endParaRPr lang="en-US" sz="1200" dirty="0"/>
+              <a:t>Llama-3.3 70B on Groq · structured JSON</a:t>
+            </a:r>
+            <a:endParaRPr lang="en-US" sz="1100" dirty="0"/>
           </a:p>
         </p:txBody>
       </p:sp>
@@ -19903,7 +19903,7 @@
                 <a:ea typeface="Calibri" pitchFamily="34" charset="-122"/>
                 <a:cs typeface="Calibri" pitchFamily="34" charset="-120"/>
               </a:rPr>
-              <a:t>⚖</a:t>
+              <a:t>🧬</a:t>
             </a:r>
             <a:endParaRPr lang="en-US" sz="2520" dirty="0"/>
           </a:p>
@@ -19942,7 +19942,7 @@
                 <a:ea typeface="Calibri" pitchFamily="34" charset="-122"/>
                 <a:cs typeface="Calibri" pitchFamily="34" charset="-120"/>
               </a:rPr>
-              <a:t>MATCH</a:t>
+              <a:t>EMBEDDINGS</a:t>
             </a:r>
             <a:endParaRPr lang="en-US" sz="1400" dirty="0"/>
           </a:p>
@@ -19973,7 +19973,7 @@
               <a:buNone/>
             </a:pPr>
             <a:r>
-              <a:rPr lang="en-US" sz="1200" dirty="0">
+              <a:rPr lang="en-US" sz="1100" dirty="0">
                 <a:solidFill>
                   <a:srgbClr val="8A9ABB"/>
                 </a:solidFill>
@@ -19981,9 +19981,9 @@
                 <a:ea typeface="Calibri Light" pitchFamily="34" charset="-122"/>
                 <a:cs typeface="Calibri Light" pitchFamily="34" charset="-120"/>
               </a:rPr>
-              <a:t>Financial · Technical · Compliance</a:t>
-            </a:r>
-            <a:endParaRPr lang="en-US" sz="1200" dirty="0"/>
+              <a:t>all-MiniLM-L6-v2 · cosine similarity</a:t>
+            </a:r>
+            <a:endParaRPr lang="en-US" sz="1100" dirty="0"/>
           </a:p>
         </p:txBody>
       </p:sp>
@@ -20106,7 +20106,7 @@
                 <a:ea typeface="Calibri" pitchFamily="34" charset="-122"/>
                 <a:cs typeface="Calibri" pitchFamily="34" charset="-120"/>
               </a:rPr>
-              <a:t>📜</a:t>
+              <a:t>⚖</a:t>
             </a:r>
             <a:endParaRPr lang="en-US" sz="2520" dirty="0"/>
           </a:p>
@@ -20145,7 +20145,7 @@
                 <a:ea typeface="Calibri" pitchFamily="34" charset="-122"/>
                 <a:cs typeface="Calibri" pitchFamily="34" charset="-120"/>
               </a:rPr>
-              <a:t>EXPLAIN</a:t>
+              <a:t>RULES</a:t>
             </a:r>
             <a:endParaRPr lang="en-US" sz="1400" dirty="0"/>
           </a:p>
@@ -20176,7 +20176,7 @@
               <a:buNone/>
             </a:pPr>
             <a:r>
-              <a:rPr lang="en-US" sz="1200" dirty="0">
+              <a:rPr lang="en-US" sz="1100" dirty="0">
                 <a:solidFill>
                   <a:srgbClr val="8A9ABB"/>
                 </a:solidFill>
@@ -20184,9 +20184,9 @@
                 <a:ea typeface="Calibri Light" pitchFamily="34" charset="-122"/>
                 <a:cs typeface="Calibri Light" pitchFamily="34" charset="-120"/>
               </a:rPr>
-              <a:t>Verdict + source + confidence</a:t>
-            </a:r>
-            <a:endParaRPr lang="en-US" sz="1200" dirty="0"/>
+              <a:t>Deterministic engine · explainable</a:t>
+            </a:r>
+            <a:endParaRPr lang="en-US" sz="1100" dirty="0"/>
           </a:p>
         </p:txBody>
       </p:sp>
@@ -20289,7 +20289,7 @@
                 <a:ea typeface="Calibri" pitchFamily="34" charset="-122"/>
                 <a:cs typeface="Calibri" pitchFamily="34" charset="-120"/>
               </a:rPr>
-              <a:t>Tender criterion</a:t>
+              <a:t>OCR</a:t>
             </a:r>
             <a:endParaRPr lang="en-US" sz="1100" dirty="0"/>
           </a:p>
@@ -20322,13 +20322,13 @@
             <a:r>
               <a:rPr lang="en-US" sz="1200" dirty="0">
                 <a:solidFill>
-                  <a:srgbClr val="8A9ABB"/>
+                  <a:srgbClr val="E8ECF4"/>
                 </a:solidFill>
                 <a:latin typeface="Calibri Light" pitchFamily="34" charset="0"/>
                 <a:ea typeface="Calibri Light" pitchFamily="34" charset="-122"/>
                 <a:cs typeface="Calibri Light" pitchFamily="34" charset="-120"/>
               </a:rPr>
-              <a:t>"Minimum annual turnover of Rs. 5 crore"</a:t>
+              <a:t>PyMuPDF lifts the typed NIT text in 0.3 s</a:t>
             </a:r>
             <a:endParaRPr lang="en-US" sz="1200" dirty="0"/>
           </a:p>
@@ -20367,7 +20367,7 @@
                 <a:ea typeface="Calibri" pitchFamily="34" charset="-122"/>
                 <a:cs typeface="Calibri" pitchFamily="34" charset="-120"/>
               </a:rPr>
-              <a:t>Parsed amount</a:t>
+              <a:t>LLM extracts</a:t>
             </a:r>
             <a:endParaRPr lang="en-US" sz="1100" dirty="0"/>
           </a:p>
@@ -20406,7 +20406,7 @@
                 <a:ea typeface="Calibri Light" pitchFamily="34" charset="-122"/>
                 <a:cs typeface="Calibri Light" pitchFamily="34" charset="-120"/>
               </a:rPr>
-              <a:t>50,000,000 (Indian-system parser)</a:t>
+              <a:t>Llama-3.3 70B → {criterion: "Minimum Annual Turnover", value: "₹5 crore", mandatory: true}</a:t>
             </a:r>
             <a:endParaRPr lang="en-US" sz="1200" dirty="0"/>
           </a:p>
@@ -20445,7 +20445,7 @@
                 <a:ea typeface="Calibri" pitchFamily="34" charset="-122"/>
                 <a:cs typeface="Calibri" pitchFamily="34" charset="-120"/>
               </a:rPr>
-              <a:t>Bidder evidence</a:t>
+              <a:t>Embeddings match</a:t>
             </a:r>
             <a:endParaRPr lang="en-US" sz="1100" dirty="0"/>
           </a:p>
@@ -20484,7 +20484,7 @@
                 <a:ea typeface="Calibri Light" pitchFamily="34" charset="-122"/>
                 <a:cs typeface="Calibri Light" pitchFamily="34" charset="-120"/>
               </a:rPr>
-              <a:t>"Annual Turnover (2024-25): Rs. 8.0 Crore" (financials.pdf p.2)</a:t>
+              <a:t>Bidder field "yearly_revenue" → criterion · cosine 0.78 (≥ 0.45 threshold)</a:t>
             </a:r>
             <a:endParaRPr lang="en-US" sz="1200" dirty="0"/>
           </a:p>
@@ -20523,7 +20523,7 @@
                 <a:ea typeface="Calibri" pitchFamily="34" charset="-122"/>
                 <a:cs typeface="Calibri" pitchFamily="34" charset="-120"/>
               </a:rPr>
-              <a:t>OCR · extraction · combined</a:t>
+              <a:t>Rule engine</a:t>
             </a:r>
             <a:endParaRPr lang="en-US" sz="1100" dirty="0"/>
           </a:p>
@@ -20556,13 +20556,13 @@
             <a:r>
               <a:rPr lang="en-US" sz="1200" dirty="0">
                 <a:solidFill>
-                  <a:srgbClr val="E8ECF4"/>
+                  <a:srgbClr val="00E5A0"/>
                 </a:solidFill>
                 <a:latin typeface="Calibri Light" pitchFamily="34" charset="0"/>
                 <a:ea typeface="Calibri Light" pitchFamily="34" charset="-122"/>
                 <a:cs typeface="Calibri Light" pitchFamily="34" charset="-120"/>
               </a:rPr>
-              <a:t>0.97  ·  0.92  →  0.94 confidence (high)</a:t>
+              <a:t>₹8 crore ≥ ₹5 crore → PASS  · combined confidence 0.94 (high)</a:t>
             </a:r>
             <a:endParaRPr lang="en-US" sz="1200" dirty="0"/>
           </a:p>
@@ -20601,7 +20601,7 @@
                 <a:ea typeface="Calibri" pitchFamily="34" charset="-122"/>
                 <a:cs typeface="Calibri" pitchFamily="34" charset="-120"/>
               </a:rPr>
-              <a:t>Verdict</a:t>
+              <a:t>Audit trail tag</a:t>
             </a:r>
             <a:endParaRPr lang="en-US" sz="1100" dirty="0"/>
           </a:p>
@@ -20634,13 +20634,13 @@
             <a:r>
               <a:rPr lang="en-US" sz="1200" dirty="0">
                 <a:solidFill>
-                  <a:srgbClr val="00E5A0"/>
+                  <a:srgbClr val="8A9ABB"/>
                 </a:solidFill>
                 <a:latin typeface="Calibri Light" pitchFamily="34" charset="0"/>
                 <a:ea typeface="Calibri Light" pitchFamily="34" charset="-122"/>
                 <a:cs typeface="Calibri Light" pitchFamily="34" charset="-120"/>
               </a:rPr>
-              <a:t>PASS — bidder value (₹8 cr) meets or exceeds requirement (₹5 cr)</a:t>
+              <a:t>extractor=LLM (Groq · Llama-3) · match=semantic 0.78 · verdict=rule</a:t>
             </a:r>
             <a:endParaRPr lang="en-US" sz="1200" dirty="0"/>
           </a:p>
@@ -20883,11 +20883,11 @@
         <p:spPr>
           <a:xfrm>
             <a:off x="640080" y="2286000"/>
-            <a:ext cx="5486400" cy="347472"/>
+            <a:ext cx="5486400" cy="310896"/>
           </a:xfrm>
           <a:prstGeom prst="roundRect">
             <a:avLst>
-              <a:gd name="adj" fmla="val 42105"/>
+              <a:gd name="adj" fmla="val 47059"/>
             </a:avLst>
           </a:prstGeom>
           <a:solidFill>
@@ -20910,23 +20910,23 @@
         <p:spPr>
           <a:xfrm>
             <a:off x="777240" y="2286000"/>
-            <a:ext cx="1737360" cy="347472"/>
-          </a:xfrm>
-          <a:prstGeom prst="rect">
-            <a:avLst/>
-          </a:prstGeom>
-          <a:noFill/>
-          <a:ln/>
-        </p:spPr>
-        <p:txBody>
-          <a:bodyPr wrap="square" rtlCol="0" anchor="ctr"/>
-          <a:lstStyle/>
-          <a:p>
-            <a:pPr indent="0" marL="0">
-              <a:buNone/>
-            </a:pPr>
-            <a:r>
-              <a:rPr lang="en-US" sz="1100" b="1" spc="100" kern="0" dirty="0">
+            <a:ext cx="1737360" cy="310896"/>
+          </a:xfrm>
+          <a:prstGeom prst="rect">
+            <a:avLst/>
+          </a:prstGeom>
+          <a:noFill/>
+          <a:ln/>
+        </p:spPr>
+        <p:txBody>
+          <a:bodyPr wrap="square" rtlCol="0" anchor="ctr"/>
+          <a:lstStyle/>
+          <a:p>
+            <a:pPr indent="0" marL="0">
+              <a:buNone/>
+            </a:pPr>
+            <a:r>
+              <a:rPr lang="en-US" sz="1050" b="1" spc="100" kern="0" dirty="0">
                 <a:solidFill>
                   <a:srgbClr val="475569"/>
                 </a:solidFill>
@@ -20936,7 +20936,7 @@
               </a:rPr>
               <a:t>Criterion</a:t>
             </a:r>
-            <a:endParaRPr lang="en-US" sz="1100" dirty="0"/>
+            <a:endParaRPr lang="en-US" sz="1050" dirty="0"/>
           </a:p>
         </p:txBody>
       </p:sp>
@@ -20949,23 +20949,23 @@
         <p:spPr>
           <a:xfrm>
             <a:off x="2606040" y="2286000"/>
-            <a:ext cx="3383280" cy="347472"/>
-          </a:xfrm>
-          <a:prstGeom prst="rect">
-            <a:avLst/>
-          </a:prstGeom>
-          <a:noFill/>
-          <a:ln/>
-        </p:spPr>
-        <p:txBody>
-          <a:bodyPr wrap="square" rtlCol="0" anchor="ctr"/>
-          <a:lstStyle/>
-          <a:p>
-            <a:pPr indent="0" marL="0">
-              <a:buNone/>
-            </a:pPr>
-            <a:r>
-              <a:rPr lang="en-US" sz="1150" dirty="0">
+            <a:ext cx="3383280" cy="310896"/>
+          </a:xfrm>
+          <a:prstGeom prst="rect">
+            <a:avLst/>
+          </a:prstGeom>
+          <a:noFill/>
+          <a:ln/>
+        </p:spPr>
+        <p:txBody>
+          <a:bodyPr wrap="square" rtlCol="0" anchor="ctr"/>
+          <a:lstStyle/>
+          <a:p>
+            <a:pPr indent="0" marL="0">
+              <a:buNone/>
+            </a:pPr>
+            <a:r>
+              <a:rPr lang="en-US" sz="1100" dirty="0">
                 <a:solidFill>
                   <a:srgbClr val="1E293B"/>
                 </a:solidFill>
@@ -20975,7 +20975,7 @@
               </a:rPr>
               <a:t>Minimum Annual Turnover (₹5 crore)</a:t>
             </a:r>
-            <a:endParaRPr lang="en-US" sz="1150" dirty="0"/>
+            <a:endParaRPr lang="en-US" sz="1100" dirty="0"/>
           </a:p>
         </p:txBody>
       </p:sp>
@@ -20987,12 +20987,12 @@
         </p:nvSpPr>
         <p:spPr>
           <a:xfrm>
-            <a:off x="640080" y="2697480"/>
-            <a:ext cx="5486400" cy="347472"/>
+            <a:off x="640080" y="2651760"/>
+            <a:ext cx="5486400" cy="310896"/>
           </a:xfrm>
           <a:prstGeom prst="roundRect">
             <a:avLst>
-              <a:gd name="adj" fmla="val 42105"/>
+              <a:gd name="adj" fmla="val 47059"/>
             </a:avLst>
           </a:prstGeom>
           <a:solidFill>
@@ -21014,24 +21014,24 @@
         </p:nvSpPr>
         <p:spPr>
           <a:xfrm>
-            <a:off x="777240" y="2697480"/>
-            <a:ext cx="1737360" cy="347472"/>
-          </a:xfrm>
-          <a:prstGeom prst="rect">
-            <a:avLst/>
-          </a:prstGeom>
-          <a:noFill/>
-          <a:ln/>
-        </p:spPr>
-        <p:txBody>
-          <a:bodyPr wrap="square" rtlCol="0" anchor="ctr"/>
-          <a:lstStyle/>
-          <a:p>
-            <a:pPr indent="0" marL="0">
-              <a:buNone/>
-            </a:pPr>
-            <a:r>
-              <a:rPr lang="en-US" sz="1100" b="1" spc="100" kern="0" dirty="0">
+            <a:off x="777240" y="2651760"/>
+            <a:ext cx="1737360" cy="310896"/>
+          </a:xfrm>
+          <a:prstGeom prst="rect">
+            <a:avLst/>
+          </a:prstGeom>
+          <a:noFill/>
+          <a:ln/>
+        </p:spPr>
+        <p:txBody>
+          <a:bodyPr wrap="square" rtlCol="0" anchor="ctr"/>
+          <a:lstStyle/>
+          <a:p>
+            <a:pPr indent="0" marL="0">
+              <a:buNone/>
+            </a:pPr>
+            <a:r>
+              <a:rPr lang="en-US" sz="1050" b="1" spc="100" kern="0" dirty="0">
                 <a:solidFill>
                   <a:srgbClr val="475569"/>
                 </a:solidFill>
@@ -21041,7 +21041,7 @@
               </a:rPr>
               <a:t>Bidder value</a:t>
             </a:r>
-            <a:endParaRPr lang="en-US" sz="1100" dirty="0"/>
+            <a:endParaRPr lang="en-US" sz="1050" dirty="0"/>
           </a:p>
         </p:txBody>
       </p:sp>
@@ -21053,24 +21053,24 @@
         </p:nvSpPr>
         <p:spPr>
           <a:xfrm>
-            <a:off x="2606040" y="2697480"/>
-            <a:ext cx="3383280" cy="347472"/>
-          </a:xfrm>
-          <a:prstGeom prst="rect">
-            <a:avLst/>
-          </a:prstGeom>
-          <a:noFill/>
-          <a:ln/>
-        </p:spPr>
-        <p:txBody>
-          <a:bodyPr wrap="square" rtlCol="0" anchor="ctr"/>
-          <a:lstStyle/>
-          <a:p>
-            <a:pPr indent="0" marL="0">
-              <a:buNone/>
-            </a:pPr>
-            <a:r>
-              <a:rPr lang="en-US" sz="1150" dirty="0">
+            <a:off x="2606040" y="2651760"/>
+            <a:ext cx="3383280" cy="310896"/>
+          </a:xfrm>
+          <a:prstGeom prst="rect">
+            <a:avLst/>
+          </a:prstGeom>
+          <a:noFill/>
+          <a:ln/>
+        </p:spPr>
+        <p:txBody>
+          <a:bodyPr wrap="square" rtlCol="0" anchor="ctr"/>
+          <a:lstStyle/>
+          <a:p>
+            <a:pPr indent="0" marL="0">
+              <a:buNone/>
+            </a:pPr>
+            <a:r>
+              <a:rPr lang="en-US" sz="1100" dirty="0">
                 <a:solidFill>
                   <a:srgbClr val="1E293B"/>
                 </a:solidFill>
@@ -21080,7 +21080,7 @@
               </a:rPr>
               <a:t>₹8.0 Crore</a:t>
             </a:r>
-            <a:endParaRPr lang="en-US" sz="1150" dirty="0"/>
+            <a:endParaRPr lang="en-US" sz="1100" dirty="0"/>
           </a:p>
         </p:txBody>
       </p:sp>
@@ -21092,12 +21092,12 @@
         </p:nvSpPr>
         <p:spPr>
           <a:xfrm>
-            <a:off x="640080" y="3108960"/>
-            <a:ext cx="5486400" cy="347472"/>
+            <a:off x="640080" y="3017520"/>
+            <a:ext cx="5486400" cy="310896"/>
           </a:xfrm>
           <a:prstGeom prst="roundRect">
             <a:avLst>
-              <a:gd name="adj" fmla="val 42105"/>
+              <a:gd name="adj" fmla="val 47059"/>
             </a:avLst>
           </a:prstGeom>
           <a:solidFill>
@@ -21119,24 +21119,24 @@
         </p:nvSpPr>
         <p:spPr>
           <a:xfrm>
-            <a:off x="777240" y="3108960"/>
-            <a:ext cx="1737360" cy="347472"/>
-          </a:xfrm>
-          <a:prstGeom prst="rect">
-            <a:avLst/>
-          </a:prstGeom>
-          <a:noFill/>
-          <a:ln/>
-        </p:spPr>
-        <p:txBody>
-          <a:bodyPr wrap="square" rtlCol="0" anchor="ctr"/>
-          <a:lstStyle/>
-          <a:p>
-            <a:pPr indent="0" marL="0">
-              <a:buNone/>
-            </a:pPr>
-            <a:r>
-              <a:rPr lang="en-US" sz="1100" b="1" spc="100" kern="0" dirty="0">
+            <a:off x="777240" y="3017520"/>
+            <a:ext cx="1737360" cy="310896"/>
+          </a:xfrm>
+          <a:prstGeom prst="rect">
+            <a:avLst/>
+          </a:prstGeom>
+          <a:noFill/>
+          <a:ln/>
+        </p:spPr>
+        <p:txBody>
+          <a:bodyPr wrap="square" rtlCol="0" anchor="ctr"/>
+          <a:lstStyle/>
+          <a:p>
+            <a:pPr indent="0" marL="0">
+              <a:buNone/>
+            </a:pPr>
+            <a:r>
+              <a:rPr lang="en-US" sz="1050" b="1" spc="100" kern="0" dirty="0">
                 <a:solidFill>
                   <a:srgbClr val="475569"/>
                 </a:solidFill>
@@ -21146,7 +21146,7 @@
               </a:rPr>
               <a:t>Decision</a:t>
             </a:r>
-            <a:endParaRPr lang="en-US" sz="1100" dirty="0"/>
+            <a:endParaRPr lang="en-US" sz="1050" dirty="0"/>
           </a:p>
         </p:txBody>
       </p:sp>
@@ -21158,24 +21158,24 @@
         </p:nvSpPr>
         <p:spPr>
           <a:xfrm>
-            <a:off x="2606040" y="3108960"/>
-            <a:ext cx="3383280" cy="347472"/>
-          </a:xfrm>
-          <a:prstGeom prst="rect">
-            <a:avLst/>
-          </a:prstGeom>
-          <a:noFill/>
-          <a:ln/>
-        </p:spPr>
-        <p:txBody>
-          <a:bodyPr wrap="square" rtlCol="0" anchor="ctr"/>
-          <a:lstStyle/>
-          <a:p>
-            <a:pPr indent="0" marL="0">
-              <a:buNone/>
-            </a:pPr>
-            <a:r>
-              <a:rPr lang="en-US" sz="1150" dirty="0">
+            <a:off x="2606040" y="3017520"/>
+            <a:ext cx="3383280" cy="310896"/>
+          </a:xfrm>
+          <a:prstGeom prst="rect">
+            <a:avLst/>
+          </a:prstGeom>
+          <a:noFill/>
+          <a:ln/>
+        </p:spPr>
+        <p:txBody>
+          <a:bodyPr wrap="square" rtlCol="0" anchor="ctr"/>
+          <a:lstStyle/>
+          <a:p>
+            <a:pPr indent="0" marL="0">
+              <a:buNone/>
+            </a:pPr>
+            <a:r>
+              <a:rPr lang="en-US" sz="1100" dirty="0">
                 <a:solidFill>
                   <a:srgbClr val="1E293B"/>
                 </a:solidFill>
@@ -21185,7 +21185,7 @@
               </a:rPr>
               <a:t>PASS</a:t>
             </a:r>
-            <a:endParaRPr lang="en-US" sz="1150" dirty="0"/>
+            <a:endParaRPr lang="en-US" sz="1100" dirty="0"/>
           </a:p>
         </p:txBody>
       </p:sp>
@@ -21197,12 +21197,12 @@
         </p:nvSpPr>
         <p:spPr>
           <a:xfrm>
-            <a:off x="640080" y="3520440"/>
-            <a:ext cx="5486400" cy="347472"/>
+            <a:off x="640080" y="3383280"/>
+            <a:ext cx="5486400" cy="310896"/>
           </a:xfrm>
           <a:prstGeom prst="roundRect">
             <a:avLst>
-              <a:gd name="adj" fmla="val 42105"/>
+              <a:gd name="adj" fmla="val 47059"/>
             </a:avLst>
           </a:prstGeom>
           <a:solidFill>
@@ -21224,24 +21224,24 @@
         </p:nvSpPr>
         <p:spPr>
           <a:xfrm>
-            <a:off x="777240" y="3520440"/>
-            <a:ext cx="1737360" cy="347472"/>
-          </a:xfrm>
-          <a:prstGeom prst="rect">
-            <a:avLst/>
-          </a:prstGeom>
-          <a:noFill/>
-          <a:ln/>
-        </p:spPr>
-        <p:txBody>
-          <a:bodyPr wrap="square" rtlCol="0" anchor="ctr"/>
-          <a:lstStyle/>
-          <a:p>
-            <a:pPr indent="0" marL="0">
-              <a:buNone/>
-            </a:pPr>
-            <a:r>
-              <a:rPr lang="en-US" sz="1100" b="1" spc="100" kern="0" dirty="0">
+            <a:off x="777240" y="3383280"/>
+            <a:ext cx="1737360" cy="310896"/>
+          </a:xfrm>
+          <a:prstGeom prst="rect">
+            <a:avLst/>
+          </a:prstGeom>
+          <a:noFill/>
+          <a:ln/>
+        </p:spPr>
+        <p:txBody>
+          <a:bodyPr wrap="square" rtlCol="0" anchor="ctr"/>
+          <a:lstStyle/>
+          <a:p>
+            <a:pPr indent="0" marL="0">
+              <a:buNone/>
+            </a:pPr>
+            <a:r>
+              <a:rPr lang="en-US" sz="1050" b="1" spc="100" kern="0" dirty="0">
                 <a:solidFill>
                   <a:srgbClr val="475569"/>
                 </a:solidFill>
@@ -21251,7 +21251,7 @@
               </a:rPr>
               <a:t>Reason</a:t>
             </a:r>
-            <a:endParaRPr lang="en-US" sz="1100" dirty="0"/>
+            <a:endParaRPr lang="en-US" sz="1050" dirty="0"/>
           </a:p>
         </p:txBody>
       </p:sp>
@@ -21263,24 +21263,24 @@
         </p:nvSpPr>
         <p:spPr>
           <a:xfrm>
-            <a:off x="2606040" y="3520440"/>
-            <a:ext cx="3383280" cy="347472"/>
-          </a:xfrm>
-          <a:prstGeom prst="rect">
-            <a:avLst/>
-          </a:prstGeom>
-          <a:noFill/>
-          <a:ln/>
-        </p:spPr>
-        <p:txBody>
-          <a:bodyPr wrap="square" rtlCol="0" anchor="ctr"/>
-          <a:lstStyle/>
-          <a:p>
-            <a:pPr indent="0" marL="0">
-              <a:buNone/>
-            </a:pPr>
-            <a:r>
-              <a:rPr lang="en-US" sz="1150" dirty="0">
+            <a:off x="2606040" y="3383280"/>
+            <a:ext cx="3383280" cy="310896"/>
+          </a:xfrm>
+          <a:prstGeom prst="rect">
+            <a:avLst/>
+          </a:prstGeom>
+          <a:noFill/>
+          <a:ln/>
+        </p:spPr>
+        <p:txBody>
+          <a:bodyPr wrap="square" rtlCol="0" anchor="ctr"/>
+          <a:lstStyle/>
+          <a:p>
+            <a:pPr indent="0" marL="0">
+              <a:buNone/>
+            </a:pPr>
+            <a:r>
+              <a:rPr lang="en-US" sz="1100" dirty="0">
                 <a:solidFill>
                   <a:srgbClr val="1E293B"/>
                 </a:solidFill>
@@ -21290,7 +21290,7 @@
               </a:rPr>
               <a:t>Bidder value meets or exceeds requirement</a:t>
             </a:r>
-            <a:endParaRPr lang="en-US" sz="1150" dirty="0"/>
+            <a:endParaRPr lang="en-US" sz="1100" dirty="0"/>
           </a:p>
         </p:txBody>
       </p:sp>
@@ -21302,12 +21302,12 @@
         </p:nvSpPr>
         <p:spPr>
           <a:xfrm>
-            <a:off x="640080" y="3931920"/>
-            <a:ext cx="5486400" cy="347472"/>
+            <a:off x="640080" y="3749040"/>
+            <a:ext cx="5486400" cy="310896"/>
           </a:xfrm>
           <a:prstGeom prst="roundRect">
             <a:avLst>
-              <a:gd name="adj" fmla="val 42105"/>
+              <a:gd name="adj" fmla="val 47059"/>
             </a:avLst>
           </a:prstGeom>
           <a:solidFill>
@@ -21329,24 +21329,24 @@
         </p:nvSpPr>
         <p:spPr>
           <a:xfrm>
-            <a:off x="777240" y="3931920"/>
-            <a:ext cx="1737360" cy="347472"/>
-          </a:xfrm>
-          <a:prstGeom prst="rect">
-            <a:avLst/>
-          </a:prstGeom>
-          <a:noFill/>
-          <a:ln/>
-        </p:spPr>
-        <p:txBody>
-          <a:bodyPr wrap="square" rtlCol="0" anchor="ctr"/>
-          <a:lstStyle/>
-          <a:p>
-            <a:pPr indent="0" marL="0">
-              <a:buNone/>
-            </a:pPr>
-            <a:r>
-              <a:rPr lang="en-US" sz="1100" b="1" spc="100" kern="0" dirty="0">
+            <a:off x="777240" y="3749040"/>
+            <a:ext cx="1737360" cy="310896"/>
+          </a:xfrm>
+          <a:prstGeom prst="rect">
+            <a:avLst/>
+          </a:prstGeom>
+          <a:noFill/>
+          <a:ln/>
+        </p:spPr>
+        <p:txBody>
+          <a:bodyPr wrap="square" rtlCol="0" anchor="ctr"/>
+          <a:lstStyle/>
+          <a:p>
+            <a:pPr indent="0" marL="0">
+              <a:buNone/>
+            </a:pPr>
+            <a:r>
+              <a:rPr lang="en-US" sz="1050" b="1" spc="100" kern="0" dirty="0">
                 <a:solidFill>
                   <a:srgbClr val="475569"/>
                 </a:solidFill>
@@ -21356,7 +21356,7 @@
               </a:rPr>
               <a:t>Source doc</a:t>
             </a:r>
-            <a:endParaRPr lang="en-US" sz="1100" dirty="0"/>
+            <a:endParaRPr lang="en-US" sz="1050" dirty="0"/>
           </a:p>
         </p:txBody>
       </p:sp>
@@ -21368,24 +21368,24 @@
         </p:nvSpPr>
         <p:spPr>
           <a:xfrm>
-            <a:off x="2606040" y="3931920"/>
-            <a:ext cx="3383280" cy="347472"/>
-          </a:xfrm>
-          <a:prstGeom prst="rect">
-            <a:avLst/>
-          </a:prstGeom>
-          <a:noFill/>
-          <a:ln/>
-        </p:spPr>
-        <p:txBody>
-          <a:bodyPr wrap="square" rtlCol="0" anchor="ctr"/>
-          <a:lstStyle/>
-          <a:p>
-            <a:pPr indent="0" marL="0">
-              <a:buNone/>
-            </a:pPr>
-            <a:r>
-              <a:rPr lang="en-US" sz="1150" dirty="0">
+            <a:off x="2606040" y="3749040"/>
+            <a:ext cx="3383280" cy="310896"/>
+          </a:xfrm>
+          <a:prstGeom prst="rect">
+            <a:avLst/>
+          </a:prstGeom>
+          <a:noFill/>
+          <a:ln/>
+        </p:spPr>
+        <p:txBody>
+          <a:bodyPr wrap="square" rtlCol="0" anchor="ctr"/>
+          <a:lstStyle/>
+          <a:p>
+            <a:pPr indent="0" marL="0">
+              <a:buNone/>
+            </a:pPr>
+            <a:r>
+              <a:rPr lang="en-US" sz="1100" dirty="0">
                 <a:solidFill>
                   <a:srgbClr val="1E293B"/>
                 </a:solidFill>
@@ -21393,9 +21393,9 @@
                 <a:ea typeface="Calibri Light" pitchFamily="34" charset="-122"/>
                 <a:cs typeface="Calibri Light" pitchFamily="34" charset="-120"/>
               </a:rPr>
-              <a:t>financials.pdf</a:t>
-            </a:r>
-            <a:endParaRPr lang="en-US" sz="1150" dirty="0"/>
+              <a:t>financials.pdf · page 2</a:t>
+            </a:r>
+            <a:endParaRPr lang="en-US" sz="1100" dirty="0"/>
           </a:p>
         </p:txBody>
       </p:sp>
@@ -21407,12 +21407,12 @@
         </p:nvSpPr>
         <p:spPr>
           <a:xfrm>
-            <a:off x="640080" y="4343400"/>
-            <a:ext cx="5486400" cy="347472"/>
+            <a:off x="640080" y="4114800"/>
+            <a:ext cx="5486400" cy="310896"/>
           </a:xfrm>
           <a:prstGeom prst="roundRect">
             <a:avLst>
-              <a:gd name="adj" fmla="val 42105"/>
+              <a:gd name="adj" fmla="val 47059"/>
             </a:avLst>
           </a:prstGeom>
           <a:solidFill>
@@ -21434,24 +21434,24 @@
         </p:nvSpPr>
         <p:spPr>
           <a:xfrm>
-            <a:off x="777240" y="4343400"/>
-            <a:ext cx="1737360" cy="347472"/>
-          </a:xfrm>
-          <a:prstGeom prst="rect">
-            <a:avLst/>
-          </a:prstGeom>
-          <a:noFill/>
-          <a:ln/>
-        </p:spPr>
-        <p:txBody>
-          <a:bodyPr wrap="square" rtlCol="0" anchor="ctr"/>
-          <a:lstStyle/>
-          <a:p>
-            <a:pPr indent="0" marL="0">
-              <a:buNone/>
-            </a:pPr>
-            <a:r>
-              <a:rPr lang="en-US" sz="1100" b="1" spc="100" kern="0" dirty="0">
+            <a:off x="777240" y="4114800"/>
+            <a:ext cx="1737360" cy="310896"/>
+          </a:xfrm>
+          <a:prstGeom prst="rect">
+            <a:avLst/>
+          </a:prstGeom>
+          <a:noFill/>
+          <a:ln/>
+        </p:spPr>
+        <p:txBody>
+          <a:bodyPr wrap="square" rtlCol="0" anchor="ctr"/>
+          <a:lstStyle/>
+          <a:p>
+            <a:pPr indent="0" marL="0">
+              <a:buNone/>
+            </a:pPr>
+            <a:r>
+              <a:rPr lang="en-US" sz="1050" b="1" spc="100" kern="0" dirty="0">
                 <a:solidFill>
                   <a:srgbClr val="475569"/>
                 </a:solidFill>
@@ -21459,9 +21459,9 @@
                 <a:ea typeface="Calibri" pitchFamily="34" charset="-122"/>
                 <a:cs typeface="Calibri" pitchFamily="34" charset="-120"/>
               </a:rPr>
-              <a:t>Page</a:t>
-            </a:r>
-            <a:endParaRPr lang="en-US" sz="1100" dirty="0"/>
+              <a:t>Confidence</a:t>
+            </a:r>
+            <a:endParaRPr lang="en-US" sz="1050" dirty="0"/>
           </a:p>
         </p:txBody>
       </p:sp>
@@ -21473,24 +21473,24 @@
         </p:nvSpPr>
         <p:spPr>
           <a:xfrm>
-            <a:off x="2606040" y="4343400"/>
-            <a:ext cx="3383280" cy="347472"/>
-          </a:xfrm>
-          <a:prstGeom prst="rect">
-            <a:avLst/>
-          </a:prstGeom>
-          <a:noFill/>
-          <a:ln/>
-        </p:spPr>
-        <p:txBody>
-          <a:bodyPr wrap="square" rtlCol="0" anchor="ctr"/>
-          <a:lstStyle/>
-          <a:p>
-            <a:pPr indent="0" marL="0">
-              <a:buNone/>
-            </a:pPr>
-            <a:r>
-              <a:rPr lang="en-US" sz="1150" dirty="0">
+            <a:off x="2606040" y="4114800"/>
+            <a:ext cx="3383280" cy="310896"/>
+          </a:xfrm>
+          <a:prstGeom prst="rect">
+            <a:avLst/>
+          </a:prstGeom>
+          <a:noFill/>
+          <a:ln/>
+        </p:spPr>
+        <p:txBody>
+          <a:bodyPr wrap="square" rtlCol="0" anchor="ctr"/>
+          <a:lstStyle/>
+          <a:p>
+            <a:pPr indent="0" marL="0">
+              <a:buNone/>
+            </a:pPr>
+            <a:r>
+              <a:rPr lang="en-US" sz="1100" dirty="0">
                 <a:solidFill>
                   <a:srgbClr val="1E293B"/>
                 </a:solidFill>
@@ -21498,9 +21498,9 @@
                 <a:ea typeface="Calibri Light" pitchFamily="34" charset="-122"/>
                 <a:cs typeface="Calibri Light" pitchFamily="34" charset="-120"/>
               </a:rPr>
-              <a:t>2</a:t>
-            </a:r>
-            <a:endParaRPr lang="en-US" sz="1150" dirty="0"/>
+              <a:t>0.94 (high) · OCR 0.97 · extraction 0.92</a:t>
+            </a:r>
+            <a:endParaRPr lang="en-US" sz="1100" dirty="0"/>
           </a:p>
         </p:txBody>
       </p:sp>
@@ -21512,12 +21512,12 @@
         </p:nvSpPr>
         <p:spPr>
           <a:xfrm>
-            <a:off x="640080" y="4754880"/>
-            <a:ext cx="5486400" cy="347472"/>
+            <a:off x="640080" y="4480560"/>
+            <a:ext cx="5486400" cy="310896"/>
           </a:xfrm>
           <a:prstGeom prst="roundRect">
             <a:avLst>
-              <a:gd name="adj" fmla="val 42105"/>
+              <a:gd name="adj" fmla="val 47059"/>
             </a:avLst>
           </a:prstGeom>
           <a:solidFill>
@@ -21539,24 +21539,24 @@
         </p:nvSpPr>
         <p:spPr>
           <a:xfrm>
-            <a:off x="777240" y="4754880"/>
-            <a:ext cx="1737360" cy="347472"/>
-          </a:xfrm>
-          <a:prstGeom prst="rect">
-            <a:avLst/>
-          </a:prstGeom>
-          <a:noFill/>
-          <a:ln/>
-        </p:spPr>
-        <p:txBody>
-          <a:bodyPr wrap="square" rtlCol="0" anchor="ctr"/>
-          <a:lstStyle/>
-          <a:p>
-            <a:pPr indent="0" marL="0">
-              <a:buNone/>
-            </a:pPr>
-            <a:r>
-              <a:rPr lang="en-US" sz="1100" b="1" spc="100" kern="0" dirty="0">
+            <a:off x="777240" y="4480560"/>
+            <a:ext cx="1737360" cy="310896"/>
+          </a:xfrm>
+          <a:prstGeom prst="rect">
+            <a:avLst/>
+          </a:prstGeom>
+          <a:noFill/>
+          <a:ln/>
+        </p:spPr>
+        <p:txBody>
+          <a:bodyPr wrap="square" rtlCol="0" anchor="ctr"/>
+          <a:lstStyle/>
+          <a:p>
+            <a:pPr indent="0" marL="0">
+              <a:buNone/>
+            </a:pPr>
+            <a:r>
+              <a:rPr lang="en-US" sz="1050" b="1" spc="100" kern="0" dirty="0">
                 <a:solidFill>
                   <a:srgbClr val="475569"/>
                 </a:solidFill>
@@ -21564,9 +21564,9 @@
                 <a:ea typeface="Calibri" pitchFamily="34" charset="-122"/>
                 <a:cs typeface="Calibri" pitchFamily="34" charset="-120"/>
               </a:rPr>
-              <a:t>Confidence</a:t>
-            </a:r>
-            <a:endParaRPr lang="en-US" sz="1100" dirty="0"/>
+              <a:t>Extractor</a:t>
+            </a:r>
+            <a:endParaRPr lang="en-US" sz="1050" dirty="0"/>
           </a:p>
         </p:txBody>
       </p:sp>
@@ -21578,24 +21578,24 @@
         </p:nvSpPr>
         <p:spPr>
           <a:xfrm>
-            <a:off x="2606040" y="4754880"/>
-            <a:ext cx="3383280" cy="347472"/>
-          </a:xfrm>
-          <a:prstGeom prst="rect">
-            <a:avLst/>
-          </a:prstGeom>
-          <a:noFill/>
-          <a:ln/>
-        </p:spPr>
-        <p:txBody>
-          <a:bodyPr wrap="square" rtlCol="0" anchor="ctr"/>
-          <a:lstStyle/>
-          <a:p>
-            <a:pPr indent="0" marL="0">
-              <a:buNone/>
-            </a:pPr>
-            <a:r>
-              <a:rPr lang="en-US" sz="1150" dirty="0">
+            <a:off x="2606040" y="4480560"/>
+            <a:ext cx="3383280" cy="310896"/>
+          </a:xfrm>
+          <a:prstGeom prst="rect">
+            <a:avLst/>
+          </a:prstGeom>
+          <a:noFill/>
+          <a:ln/>
+        </p:spPr>
+        <p:txBody>
+          <a:bodyPr wrap="square" rtlCol="0" anchor="ctr"/>
+          <a:lstStyle/>
+          <a:p>
+            <a:pPr indent="0" marL="0">
+              <a:buNone/>
+            </a:pPr>
+            <a:r>
+              <a:rPr lang="en-US" sz="1100" dirty="0">
                 <a:solidFill>
                   <a:srgbClr val="1E293B"/>
                 </a:solidFill>
@@ -21603,9 +21603,9 @@
                 <a:ea typeface="Calibri Light" pitchFamily="34" charset="-122"/>
                 <a:cs typeface="Calibri Light" pitchFamily="34" charset="-120"/>
               </a:rPr>
-              <a:t>0.94 (high)</a:t>
-            </a:r>
-            <a:endParaRPr lang="en-US" sz="1150" dirty="0"/>
+              <a:t>LLM (Groq · Llama-3.3 70B)</a:t>
+            </a:r>
+            <a:endParaRPr lang="en-US" sz="1100" dirty="0"/>
           </a:p>
         </p:txBody>
       </p:sp>
@@ -21617,12 +21617,12 @@
         </p:nvSpPr>
         <p:spPr>
           <a:xfrm>
-            <a:off x="640080" y="5166360"/>
-            <a:ext cx="5486400" cy="347472"/>
+            <a:off x="640080" y="4846320"/>
+            <a:ext cx="5486400" cy="310896"/>
           </a:xfrm>
           <a:prstGeom prst="roundRect">
             <a:avLst>
-              <a:gd name="adj" fmla="val 42105"/>
+              <a:gd name="adj" fmla="val 47059"/>
             </a:avLst>
           </a:prstGeom>
           <a:solidFill>
@@ -21644,24 +21644,24 @@
         </p:nvSpPr>
         <p:spPr>
           <a:xfrm>
-            <a:off x="777240" y="5166360"/>
-            <a:ext cx="1737360" cy="347472"/>
-          </a:xfrm>
-          <a:prstGeom prst="rect">
-            <a:avLst/>
-          </a:prstGeom>
-          <a:noFill/>
-          <a:ln/>
-        </p:spPr>
-        <p:txBody>
-          <a:bodyPr wrap="square" rtlCol="0" anchor="ctr"/>
-          <a:lstStyle/>
-          <a:p>
-            <a:pPr indent="0" marL="0">
-              <a:buNone/>
-            </a:pPr>
-            <a:r>
-              <a:rPr lang="en-US" sz="1100" b="1" spc="100" kern="0" dirty="0">
+            <a:off x="777240" y="4846320"/>
+            <a:ext cx="1737360" cy="310896"/>
+          </a:xfrm>
+          <a:prstGeom prst="rect">
+            <a:avLst/>
+          </a:prstGeom>
+          <a:noFill/>
+          <a:ln/>
+        </p:spPr>
+        <p:txBody>
+          <a:bodyPr wrap="square" rtlCol="0" anchor="ctr"/>
+          <a:lstStyle/>
+          <a:p>
+            <a:pPr indent="0" marL="0">
+              <a:buNone/>
+            </a:pPr>
+            <a:r>
+              <a:rPr lang="en-US" sz="1050" b="1" spc="100" kern="0" dirty="0">
                 <a:solidFill>
                   <a:srgbClr val="475569"/>
                 </a:solidFill>
@@ -21669,9 +21669,9 @@
                 <a:ea typeface="Calibri" pitchFamily="34" charset="-122"/>
                 <a:cs typeface="Calibri" pitchFamily="34" charset="-120"/>
               </a:rPr>
-              <a:t>Override?</a:t>
-            </a:r>
-            <a:endParaRPr lang="en-US" sz="1100" dirty="0"/>
+              <a:t>Match strategy</a:t>
+            </a:r>
+            <a:endParaRPr lang="en-US" sz="1050" dirty="0"/>
           </a:p>
         </p:txBody>
       </p:sp>
@@ -21683,24 +21683,24 @@
         </p:nvSpPr>
         <p:spPr>
           <a:xfrm>
-            <a:off x="2606040" y="5166360"/>
-            <a:ext cx="3383280" cy="347472"/>
-          </a:xfrm>
-          <a:prstGeom prst="rect">
-            <a:avLst/>
-          </a:prstGeom>
-          <a:noFill/>
-          <a:ln/>
-        </p:spPr>
-        <p:txBody>
-          <a:bodyPr wrap="square" rtlCol="0" anchor="ctr"/>
-          <a:lstStyle/>
-          <a:p>
-            <a:pPr indent="0" marL="0">
-              <a:buNone/>
-            </a:pPr>
-            <a:r>
-              <a:rPr lang="en-US" sz="1150" dirty="0">
+            <a:off x="2606040" y="4846320"/>
+            <a:ext cx="3383280" cy="310896"/>
+          </a:xfrm>
+          <a:prstGeom prst="rect">
+            <a:avLst/>
+          </a:prstGeom>
+          <a:noFill/>
+          <a:ln/>
+        </p:spPr>
+        <p:txBody>
+          <a:bodyPr wrap="square" rtlCol="0" anchor="ctr"/>
+          <a:lstStyle/>
+          <a:p>
+            <a:pPr indent="0" marL="0">
+              <a:buNone/>
+            </a:pPr>
+            <a:r>
+              <a:rPr lang="en-US" sz="1100" dirty="0">
                 <a:solidFill>
                   <a:srgbClr val="1E293B"/>
                 </a:solidFill>
@@ -21708,65 +21708,26 @@
                 <a:ea typeface="Calibri Light" pitchFamily="34" charset="-122"/>
                 <a:cs typeface="Calibri Light" pitchFamily="34" charset="-120"/>
               </a:rPr>
-              <a:t>No (admin can override inline)</a:t>
-            </a:r>
-            <a:endParaRPr lang="en-US" sz="1150" dirty="0"/>
-          </a:p>
-        </p:txBody>
-      </p:sp>
-      <p:sp>
-        <p:nvSpPr>
-          <p:cNvPr id="31" name="Text 29"/>
-          <p:cNvSpPr/>
-          <p:nvPr/>
-        </p:nvSpPr>
-        <p:spPr>
-          <a:xfrm>
-            <a:off x="6400800" y="1828800"/>
-            <a:ext cx="5029200" cy="365760"/>
-          </a:xfrm>
-          <a:prstGeom prst="rect">
-            <a:avLst/>
-          </a:prstGeom>
-          <a:noFill/>
-          <a:ln/>
-        </p:spPr>
-        <p:txBody>
-          <a:bodyPr wrap="square" rtlCol="0" anchor="ctr"/>
-          <a:lstStyle/>
-          <a:p>
-            <a:pPr indent="0" marL="0">
-              <a:buNone/>
-            </a:pPr>
-            <a:r>
-              <a:rPr lang="en-US" sz="1400" b="1" spc="120" kern="0" dirty="0">
-                <a:solidFill>
-                  <a:srgbClr val="00A77B"/>
-                </a:solidFill>
-                <a:latin typeface="Calibri" pitchFamily="34" charset="0"/>
-                <a:ea typeface="Calibri" pitchFamily="34" charset="-122"/>
-                <a:cs typeface="Calibri" pitchFamily="34" charset="-120"/>
-              </a:rPr>
-              <a:t>What we promise</a:t>
-            </a:r>
-            <a:endParaRPr lang="en-US" sz="1400" dirty="0"/>
-          </a:p>
-        </p:txBody>
-      </p:sp>
-      <p:sp>
-        <p:nvSpPr>
-          <p:cNvPr id="32" name="Shape 30"/>
-          <p:cNvSpPr/>
-          <p:nvPr/>
-        </p:nvSpPr>
-        <p:spPr>
-          <a:xfrm>
-            <a:off x="6400800" y="2286000"/>
-            <a:ext cx="5212080" cy="685800"/>
+              <a:t>🧬 Semantic similarity 0.78</a:t>
+            </a:r>
+            <a:endParaRPr lang="en-US" sz="1100" dirty="0"/>
+          </a:p>
+        </p:txBody>
+      </p:sp>
+      <p:sp>
+        <p:nvSpPr>
+          <p:cNvPr id="31" name="Shape 29"/>
+          <p:cNvSpPr/>
+          <p:nvPr/>
+        </p:nvSpPr>
+        <p:spPr>
+          <a:xfrm>
+            <a:off x="640080" y="5212080"/>
+            <a:ext cx="5486400" cy="310896"/>
           </a:xfrm>
           <a:prstGeom prst="roundRect">
             <a:avLst>
-              <a:gd name="adj" fmla="val 21333"/>
+              <a:gd name="adj" fmla="val 47059"/>
             </a:avLst>
           </a:prstGeom>
           <a:solidFill>
@@ -21782,130 +21743,130 @@
       </p:sp>
       <p:sp>
         <p:nvSpPr>
+          <p:cNvPr id="32" name="Text 30"/>
+          <p:cNvSpPr/>
+          <p:nvPr/>
+        </p:nvSpPr>
+        <p:spPr>
+          <a:xfrm>
+            <a:off x="777240" y="5212080"/>
+            <a:ext cx="1737360" cy="310896"/>
+          </a:xfrm>
+          <a:prstGeom prst="rect">
+            <a:avLst/>
+          </a:prstGeom>
+          <a:noFill/>
+          <a:ln/>
+        </p:spPr>
+        <p:txBody>
+          <a:bodyPr wrap="square" rtlCol="0" anchor="ctr"/>
+          <a:lstStyle/>
+          <a:p>
+            <a:pPr indent="0" marL="0">
+              <a:buNone/>
+            </a:pPr>
+            <a:r>
+              <a:rPr lang="en-US" sz="1050" b="1" spc="100" kern="0" dirty="0">
+                <a:solidFill>
+                  <a:srgbClr val="475569"/>
+                </a:solidFill>
+                <a:latin typeface="Calibri" pitchFamily="34" charset="0"/>
+                <a:ea typeface="Calibri" pitchFamily="34" charset="-122"/>
+                <a:cs typeface="Calibri" pitchFamily="34" charset="-120"/>
+              </a:rPr>
+              <a:t>Override?</a:t>
+            </a:r>
+            <a:endParaRPr lang="en-US" sz="1050" dirty="0"/>
+          </a:p>
+        </p:txBody>
+      </p:sp>
+      <p:sp>
+        <p:nvSpPr>
           <p:cNvPr id="33" name="Text 31"/>
           <p:cNvSpPr/>
           <p:nvPr/>
         </p:nvSpPr>
         <p:spPr>
           <a:xfrm>
-            <a:off x="6537960" y="2286000"/>
-            <a:ext cx="457200" cy="685800"/>
-          </a:xfrm>
-          <a:prstGeom prst="rect">
-            <a:avLst/>
-          </a:prstGeom>
-          <a:noFill/>
-          <a:ln/>
-        </p:spPr>
-        <p:txBody>
-          <a:bodyPr wrap="square" rtlCol="0" anchor="ctr"/>
-          <a:lstStyle/>
-          <a:p>
-            <a:pPr indent="0" marL="0">
-              <a:buNone/>
-            </a:pPr>
-            <a:r>
-              <a:rPr lang="en-US" sz="1800" dirty="0">
-                <a:solidFill>
-                  <a:srgbClr val="000000"/>
-                </a:solidFill>
-                <a:latin typeface="Calibri" pitchFamily="34" charset="0"/>
-                <a:ea typeface="Calibri" pitchFamily="34" charset="-122"/>
-                <a:cs typeface="Calibri" pitchFamily="34" charset="-120"/>
-              </a:rPr>
-              <a:t>📌</a:t>
-            </a:r>
-            <a:endParaRPr lang="en-US" sz="1800" dirty="0"/>
-          </a:p>
-        </p:txBody>
-      </p:sp>
-      <p:sp>
-        <p:nvSpPr>
-          <p:cNvPr id="34" name="Text 32"/>
-          <p:cNvSpPr/>
-          <p:nvPr/>
-        </p:nvSpPr>
-        <p:spPr>
-          <a:xfrm>
-            <a:off x="7040880" y="2359152"/>
-            <a:ext cx="4572000" cy="292608"/>
-          </a:xfrm>
-          <a:prstGeom prst="rect">
-            <a:avLst/>
-          </a:prstGeom>
-          <a:noFill/>
-          <a:ln/>
-        </p:spPr>
-        <p:txBody>
-          <a:bodyPr wrap="square" rtlCol="0" anchor="ctr"/>
-          <a:lstStyle/>
-          <a:p>
-            <a:pPr indent="0" marL="0">
-              <a:buNone/>
-            </a:pPr>
-            <a:r>
-              <a:rPr lang="en-US" sz="1200" b="1" dirty="0">
-                <a:solidFill>
-                  <a:srgbClr val="0A1628"/>
-                </a:solidFill>
-                <a:latin typeface="Calibri" pitchFamily="34" charset="0"/>
-                <a:ea typeface="Calibri" pitchFamily="34" charset="-122"/>
-                <a:cs typeface="Calibri" pitchFamily="34" charset="-120"/>
-              </a:rPr>
-              <a:t>Criterion-level traceability</a:t>
-            </a:r>
-            <a:endParaRPr lang="en-US" sz="1200" dirty="0"/>
-          </a:p>
-        </p:txBody>
-      </p:sp>
-      <p:sp>
-        <p:nvSpPr>
-          <p:cNvPr id="35" name="Text 33"/>
-          <p:cNvSpPr/>
-          <p:nvPr/>
-        </p:nvSpPr>
-        <p:spPr>
-          <a:xfrm>
-            <a:off x="7040880" y="2651760"/>
-            <a:ext cx="4572000" cy="274320"/>
-          </a:xfrm>
-          <a:prstGeom prst="rect">
-            <a:avLst/>
-          </a:prstGeom>
-          <a:noFill/>
-          <a:ln/>
-        </p:spPr>
-        <p:txBody>
-          <a:bodyPr wrap="square" rtlCol="0" anchor="ctr"/>
-          <a:lstStyle/>
-          <a:p>
-            <a:pPr indent="0" marL="0">
-              <a:buNone/>
-            </a:pPr>
-            <a:r>
-              <a:rPr lang="en-US" sz="1000" dirty="0">
-                <a:solidFill>
-                  <a:srgbClr val="475569"/>
+            <a:off x="2606040" y="5212080"/>
+            <a:ext cx="3383280" cy="310896"/>
+          </a:xfrm>
+          <a:prstGeom prst="rect">
+            <a:avLst/>
+          </a:prstGeom>
+          <a:noFill/>
+          <a:ln/>
+        </p:spPr>
+        <p:txBody>
+          <a:bodyPr wrap="square" rtlCol="0" anchor="ctr"/>
+          <a:lstStyle/>
+          <a:p>
+            <a:pPr indent="0" marL="0">
+              <a:buNone/>
+            </a:pPr>
+            <a:r>
+              <a:rPr lang="en-US" sz="1100" dirty="0">
+                <a:solidFill>
+                  <a:srgbClr val="1E293B"/>
                 </a:solidFill>
                 <a:latin typeface="Calibri Light" pitchFamily="34" charset="0"/>
                 <a:ea typeface="Calibri Light" pitchFamily="34" charset="-122"/>
                 <a:cs typeface="Calibri Light" pitchFamily="34" charset="-120"/>
               </a:rPr>
-              <a:t>No "rejected, no reason given" — the criterion is named.</a:t>
-            </a:r>
-            <a:endParaRPr lang="en-US" sz="1000" dirty="0"/>
-          </a:p>
-        </p:txBody>
-      </p:sp>
-      <p:sp>
-        <p:nvSpPr>
-          <p:cNvPr id="36" name="Shape 34"/>
-          <p:cNvSpPr/>
-          <p:nvPr/>
-        </p:nvSpPr>
-        <p:spPr>
-          <a:xfrm>
-            <a:off x="6400800" y="3063240"/>
+              <a:t>No (admin can override inline · audit-logged)</a:t>
+            </a:r>
+            <a:endParaRPr lang="en-US" sz="1100" dirty="0"/>
+          </a:p>
+        </p:txBody>
+      </p:sp>
+      <p:sp>
+        <p:nvSpPr>
+          <p:cNvPr id="34" name="Text 32"/>
+          <p:cNvSpPr/>
+          <p:nvPr/>
+        </p:nvSpPr>
+        <p:spPr>
+          <a:xfrm>
+            <a:off x="6400800" y="1828800"/>
+            <a:ext cx="5029200" cy="365760"/>
+          </a:xfrm>
+          <a:prstGeom prst="rect">
+            <a:avLst/>
+          </a:prstGeom>
+          <a:noFill/>
+          <a:ln/>
+        </p:spPr>
+        <p:txBody>
+          <a:bodyPr wrap="square" rtlCol="0" anchor="ctr"/>
+          <a:lstStyle/>
+          <a:p>
+            <a:pPr indent="0" marL="0">
+              <a:buNone/>
+            </a:pPr>
+            <a:r>
+              <a:rPr lang="en-US" sz="1400" b="1" spc="120" kern="0" dirty="0">
+                <a:solidFill>
+                  <a:srgbClr val="00A77B"/>
+                </a:solidFill>
+                <a:latin typeface="Calibri" pitchFamily="34" charset="0"/>
+                <a:ea typeface="Calibri" pitchFamily="34" charset="-122"/>
+                <a:cs typeface="Calibri" pitchFamily="34" charset="-120"/>
+              </a:rPr>
+              <a:t>What we promise</a:t>
+            </a:r>
+            <a:endParaRPr lang="en-US" sz="1400" dirty="0"/>
+          </a:p>
+        </p:txBody>
+      </p:sp>
+      <p:sp>
+        <p:nvSpPr>
+          <p:cNvPr id="35" name="Shape 33"/>
+          <p:cNvSpPr/>
+          <p:nvPr/>
+        </p:nvSpPr>
+        <p:spPr>
+          <a:xfrm>
+            <a:off x="6400800" y="2286000"/>
             <a:ext cx="5212080" cy="685800"/>
           </a:xfrm>
           <a:prstGeom prst="roundRect">
@@ -21926,40 +21887,79 @@
       </p:sp>
       <p:sp>
         <p:nvSpPr>
+          <p:cNvPr id="36" name="Text 34"/>
+          <p:cNvSpPr/>
+          <p:nvPr/>
+        </p:nvSpPr>
+        <p:spPr>
+          <a:xfrm>
+            <a:off x="6537960" y="2286000"/>
+            <a:ext cx="457200" cy="685800"/>
+          </a:xfrm>
+          <a:prstGeom prst="rect">
+            <a:avLst/>
+          </a:prstGeom>
+          <a:noFill/>
+          <a:ln/>
+        </p:spPr>
+        <p:txBody>
+          <a:bodyPr wrap="square" rtlCol="0" anchor="ctr"/>
+          <a:lstStyle/>
+          <a:p>
+            <a:pPr indent="0" marL="0">
+              <a:buNone/>
+            </a:pPr>
+            <a:r>
+              <a:rPr lang="en-US" sz="1800" dirty="0">
+                <a:solidFill>
+                  <a:srgbClr val="000000"/>
+                </a:solidFill>
+                <a:latin typeface="Calibri" pitchFamily="34" charset="0"/>
+                <a:ea typeface="Calibri" pitchFamily="34" charset="-122"/>
+                <a:cs typeface="Calibri" pitchFamily="34" charset="-120"/>
+              </a:rPr>
+              <a:t>📌</a:t>
+            </a:r>
+            <a:endParaRPr lang="en-US" sz="1800" dirty="0"/>
+          </a:p>
+        </p:txBody>
+      </p:sp>
+      <p:sp>
+        <p:nvSpPr>
           <p:cNvPr id="37" name="Text 35"/>
           <p:cNvSpPr/>
           <p:nvPr/>
         </p:nvSpPr>
         <p:spPr>
           <a:xfrm>
-            <a:off x="6537960" y="3063240"/>
-            <a:ext cx="457200" cy="685800"/>
-          </a:xfrm>
-          <a:prstGeom prst="rect">
-            <a:avLst/>
-          </a:prstGeom>
-          <a:noFill/>
-          <a:ln/>
-        </p:spPr>
-        <p:txBody>
-          <a:bodyPr wrap="square" rtlCol="0" anchor="ctr"/>
-          <a:lstStyle/>
-          <a:p>
-            <a:pPr indent="0" marL="0">
-              <a:buNone/>
-            </a:pPr>
-            <a:r>
-              <a:rPr lang="en-US" sz="1800" dirty="0">
-                <a:solidFill>
-                  <a:srgbClr val="000000"/>
-                </a:solidFill>
-                <a:latin typeface="Calibri" pitchFamily="34" charset="0"/>
-                <a:ea typeface="Calibri" pitchFamily="34" charset="-122"/>
-                <a:cs typeface="Calibri" pitchFamily="34" charset="-120"/>
-              </a:rPr>
-              <a:t>📄</a:t>
-            </a:r>
-            <a:endParaRPr lang="en-US" sz="1800" dirty="0"/>
+            <a:off x="7040880" y="2359152"/>
+            <a:ext cx="4572000" cy="292608"/>
+          </a:xfrm>
+          <a:prstGeom prst="rect">
+            <a:avLst/>
+          </a:prstGeom>
+          <a:noFill/>
+          <a:ln/>
+        </p:spPr>
+        <p:txBody>
+          <a:bodyPr wrap="square" rtlCol="0" anchor="ctr"/>
+          <a:lstStyle/>
+          <a:p>
+            <a:pPr indent="0" marL="0">
+              <a:buNone/>
+            </a:pPr>
+            <a:r>
+              <a:rPr lang="en-US" sz="1200" b="1" dirty="0">
+                <a:solidFill>
+                  <a:srgbClr val="0A1628"/>
+                </a:solidFill>
+                <a:latin typeface="Calibri" pitchFamily="34" charset="0"/>
+                <a:ea typeface="Calibri" pitchFamily="34" charset="-122"/>
+                <a:cs typeface="Calibri" pitchFamily="34" charset="-120"/>
+              </a:rPr>
+              <a:t>Criterion-level traceability</a:t>
+            </a:r>
+            <a:endParaRPr lang="en-US" sz="1200" dirty="0"/>
           </a:p>
         </p:txBody>
       </p:sp>
@@ -21971,46 +21971,7 @@
         </p:nvSpPr>
         <p:spPr>
           <a:xfrm>
-            <a:off x="7040880" y="3136392"/>
-            <a:ext cx="4572000" cy="292608"/>
-          </a:xfrm>
-          <a:prstGeom prst="rect">
-            <a:avLst/>
-          </a:prstGeom>
-          <a:noFill/>
-          <a:ln/>
-        </p:spPr>
-        <p:txBody>
-          <a:bodyPr wrap="square" rtlCol="0" anchor="ctr"/>
-          <a:lstStyle/>
-          <a:p>
-            <a:pPr indent="0" marL="0">
-              <a:buNone/>
-            </a:pPr>
-            <a:r>
-              <a:rPr lang="en-US" sz="1200" b="1" dirty="0">
-                <a:solidFill>
-                  <a:srgbClr val="0A1628"/>
-                </a:solidFill>
-                <a:latin typeface="Calibri" pitchFamily="34" charset="0"/>
-                <a:ea typeface="Calibri" pitchFamily="34" charset="-122"/>
-                <a:cs typeface="Calibri" pitchFamily="34" charset="-120"/>
-              </a:rPr>
-              <a:t>Document-level citation</a:t>
-            </a:r>
-            <a:endParaRPr lang="en-US" sz="1200" dirty="0"/>
-          </a:p>
-        </p:txBody>
-      </p:sp>
-      <p:sp>
-        <p:nvSpPr>
-          <p:cNvPr id="39" name="Text 37"/>
-          <p:cNvSpPr/>
-          <p:nvPr/>
-        </p:nvSpPr>
-        <p:spPr>
-          <a:xfrm>
-            <a:off x="7040880" y="3429000"/>
+            <a:off x="7040880" y="2651760"/>
             <a:ext cx="4572000" cy="274320"/>
           </a:xfrm>
           <a:prstGeom prst="rect">
@@ -22035,7 +21996,7 @@
                 <a:ea typeface="Calibri Light" pitchFamily="34" charset="-122"/>
                 <a:cs typeface="Calibri Light" pitchFamily="34" charset="-120"/>
               </a:rPr>
-              <a:t>Source filename + page number on every result.</a:t>
+              <a:t>No "rejected, no reason given" — the criterion is named.</a:t>
             </a:r>
             <a:endParaRPr lang="en-US" sz="1000" dirty="0"/>
           </a:p>
@@ -22043,13 +22004,13 @@
       </p:sp>
       <p:sp>
         <p:nvSpPr>
-          <p:cNvPr id="40" name="Shape 38"/>
-          <p:cNvSpPr/>
-          <p:nvPr/>
-        </p:nvSpPr>
-        <p:spPr>
-          <a:xfrm>
-            <a:off x="6400800" y="3840480"/>
+          <p:cNvPr id="39" name="Shape 37"/>
+          <p:cNvSpPr/>
+          <p:nvPr/>
+        </p:nvSpPr>
+        <p:spPr>
+          <a:xfrm>
+            <a:off x="6400800" y="3063240"/>
             <a:ext cx="5212080" cy="685800"/>
           </a:xfrm>
           <a:prstGeom prst="roundRect">
@@ -22070,40 +22031,79 @@
       </p:sp>
       <p:sp>
         <p:nvSpPr>
+          <p:cNvPr id="40" name="Text 38"/>
+          <p:cNvSpPr/>
+          <p:nvPr/>
+        </p:nvSpPr>
+        <p:spPr>
+          <a:xfrm>
+            <a:off x="6537960" y="3063240"/>
+            <a:ext cx="457200" cy="685800"/>
+          </a:xfrm>
+          <a:prstGeom prst="rect">
+            <a:avLst/>
+          </a:prstGeom>
+          <a:noFill/>
+          <a:ln/>
+        </p:spPr>
+        <p:txBody>
+          <a:bodyPr wrap="square" rtlCol="0" anchor="ctr"/>
+          <a:lstStyle/>
+          <a:p>
+            <a:pPr indent="0" marL="0">
+              <a:buNone/>
+            </a:pPr>
+            <a:r>
+              <a:rPr lang="en-US" sz="1800" dirty="0">
+                <a:solidFill>
+                  <a:srgbClr val="000000"/>
+                </a:solidFill>
+                <a:latin typeface="Calibri" pitchFamily="34" charset="0"/>
+                <a:ea typeface="Calibri" pitchFamily="34" charset="-122"/>
+                <a:cs typeface="Calibri" pitchFamily="34" charset="-120"/>
+              </a:rPr>
+              <a:t>📄</a:t>
+            </a:r>
+            <a:endParaRPr lang="en-US" sz="1800" dirty="0"/>
+          </a:p>
+        </p:txBody>
+      </p:sp>
+      <p:sp>
+        <p:nvSpPr>
           <p:cNvPr id="41" name="Text 39"/>
           <p:cNvSpPr/>
           <p:nvPr/>
         </p:nvSpPr>
         <p:spPr>
           <a:xfrm>
-            <a:off x="6537960" y="3840480"/>
-            <a:ext cx="457200" cy="685800"/>
-          </a:xfrm>
-          <a:prstGeom prst="rect">
-            <a:avLst/>
-          </a:prstGeom>
-          <a:noFill/>
-          <a:ln/>
-        </p:spPr>
-        <p:txBody>
-          <a:bodyPr wrap="square" rtlCol="0" anchor="ctr"/>
-          <a:lstStyle/>
-          <a:p>
-            <a:pPr indent="0" marL="0">
-              <a:buNone/>
-            </a:pPr>
-            <a:r>
-              <a:rPr lang="en-US" sz="1800" dirty="0">
-                <a:solidFill>
-                  <a:srgbClr val="000000"/>
-                </a:solidFill>
-                <a:latin typeface="Calibri" pitchFamily="34" charset="0"/>
-                <a:ea typeface="Calibri" pitchFamily="34" charset="-122"/>
-                <a:cs typeface="Calibri" pitchFamily="34" charset="-120"/>
-              </a:rPr>
-              <a:t>⚠️</a:t>
-            </a:r>
-            <a:endParaRPr lang="en-US" sz="1800" dirty="0"/>
+            <a:off x="7040880" y="3136392"/>
+            <a:ext cx="4572000" cy="292608"/>
+          </a:xfrm>
+          <a:prstGeom prst="rect">
+            <a:avLst/>
+          </a:prstGeom>
+          <a:noFill/>
+          <a:ln/>
+        </p:spPr>
+        <p:txBody>
+          <a:bodyPr wrap="square" rtlCol="0" anchor="ctr"/>
+          <a:lstStyle/>
+          <a:p>
+            <a:pPr indent="0" marL="0">
+              <a:buNone/>
+            </a:pPr>
+            <a:r>
+              <a:rPr lang="en-US" sz="1200" b="1" dirty="0">
+                <a:solidFill>
+                  <a:srgbClr val="0A1628"/>
+                </a:solidFill>
+                <a:latin typeface="Calibri" pitchFamily="34" charset="0"/>
+                <a:ea typeface="Calibri" pitchFamily="34" charset="-122"/>
+                <a:cs typeface="Calibri" pitchFamily="34" charset="-120"/>
+              </a:rPr>
+              <a:t>Document-level citation</a:t>
+            </a:r>
+            <a:endParaRPr lang="en-US" sz="1200" dirty="0"/>
           </a:p>
         </p:txBody>
       </p:sp>
@@ -22115,46 +22115,7 @@
         </p:nvSpPr>
         <p:spPr>
           <a:xfrm>
-            <a:off x="7040880" y="3913632"/>
-            <a:ext cx="4572000" cy="292608"/>
-          </a:xfrm>
-          <a:prstGeom prst="rect">
-            <a:avLst/>
-          </a:prstGeom>
-          <a:noFill/>
-          <a:ln/>
-        </p:spPr>
-        <p:txBody>
-          <a:bodyPr wrap="square" rtlCol="0" anchor="ctr"/>
-          <a:lstStyle/>
-          <a:p>
-            <a:pPr indent="0" marL="0">
-              <a:buNone/>
-            </a:pPr>
-            <a:r>
-              <a:rPr lang="en-US" sz="1200" b="1" dirty="0">
-                <a:solidFill>
-                  <a:srgbClr val="0A1628"/>
-                </a:solidFill>
-                <a:latin typeface="Calibri" pitchFamily="34" charset="0"/>
-                <a:ea typeface="Calibri" pitchFamily="34" charset="-122"/>
-                <a:cs typeface="Calibri" pitchFamily="34" charset="-120"/>
-              </a:rPr>
-              <a:t>No silent rejections</a:t>
-            </a:r>
-            <a:endParaRPr lang="en-US" sz="1200" dirty="0"/>
-          </a:p>
-        </p:txBody>
-      </p:sp>
-      <p:sp>
-        <p:nvSpPr>
-          <p:cNvPr id="43" name="Text 41"/>
-          <p:cNvSpPr/>
-          <p:nvPr/>
-        </p:nvSpPr>
-        <p:spPr>
-          <a:xfrm>
-            <a:off x="7040880" y="4206240"/>
+            <a:off x="7040880" y="3429000"/>
             <a:ext cx="4572000" cy="274320"/>
           </a:xfrm>
           <a:prstGeom prst="rect">
@@ -22179,7 +22140,7 @@
                 <a:ea typeface="Calibri Light" pitchFamily="34" charset="-122"/>
                 <a:cs typeface="Calibri Light" pitchFamily="34" charset="-120"/>
               </a:rPr>
-              <a:t>Ambiguous values automatically routed to NEED_REVIEW.</a:t>
+              <a:t>Source filename + page number on every result.</a:t>
             </a:r>
             <a:endParaRPr lang="en-US" sz="1000" dirty="0"/>
           </a:p>
@@ -22187,13 +22148,13 @@
       </p:sp>
       <p:sp>
         <p:nvSpPr>
-          <p:cNvPr id="44" name="Shape 42"/>
-          <p:cNvSpPr/>
-          <p:nvPr/>
-        </p:nvSpPr>
-        <p:spPr>
-          <a:xfrm>
-            <a:off x="6400800" y="4617720"/>
+          <p:cNvPr id="43" name="Shape 41"/>
+          <p:cNvSpPr/>
+          <p:nvPr/>
+        </p:nvSpPr>
+        <p:spPr>
+          <a:xfrm>
+            <a:off x="6400800" y="3840480"/>
             <a:ext cx="5212080" cy="685800"/>
           </a:xfrm>
           <a:prstGeom prst="roundRect">
@@ -22214,40 +22175,79 @@
       </p:sp>
       <p:sp>
         <p:nvSpPr>
+          <p:cNvPr id="44" name="Text 42"/>
+          <p:cNvSpPr/>
+          <p:nvPr/>
+        </p:nvSpPr>
+        <p:spPr>
+          <a:xfrm>
+            <a:off x="6537960" y="3840480"/>
+            <a:ext cx="457200" cy="685800"/>
+          </a:xfrm>
+          <a:prstGeom prst="rect">
+            <a:avLst/>
+          </a:prstGeom>
+          <a:noFill/>
+          <a:ln/>
+        </p:spPr>
+        <p:txBody>
+          <a:bodyPr wrap="square" rtlCol="0" anchor="ctr"/>
+          <a:lstStyle/>
+          <a:p>
+            <a:pPr indent="0" marL="0">
+              <a:buNone/>
+            </a:pPr>
+            <a:r>
+              <a:rPr lang="en-US" sz="1800" dirty="0">
+                <a:solidFill>
+                  <a:srgbClr val="000000"/>
+                </a:solidFill>
+                <a:latin typeface="Calibri" pitchFamily="34" charset="0"/>
+                <a:ea typeface="Calibri" pitchFamily="34" charset="-122"/>
+                <a:cs typeface="Calibri" pitchFamily="34" charset="-120"/>
+              </a:rPr>
+              <a:t>⚠️</a:t>
+            </a:r>
+            <a:endParaRPr lang="en-US" sz="1800" dirty="0"/>
+          </a:p>
+        </p:txBody>
+      </p:sp>
+      <p:sp>
+        <p:nvSpPr>
           <p:cNvPr id="45" name="Text 43"/>
           <p:cNvSpPr/>
           <p:nvPr/>
         </p:nvSpPr>
         <p:spPr>
           <a:xfrm>
-            <a:off x="6537960" y="4617720"/>
-            <a:ext cx="457200" cy="685800"/>
-          </a:xfrm>
-          <a:prstGeom prst="rect">
-            <a:avLst/>
-          </a:prstGeom>
-          <a:noFill/>
-          <a:ln/>
-        </p:spPr>
-        <p:txBody>
-          <a:bodyPr wrap="square" rtlCol="0" anchor="ctr"/>
-          <a:lstStyle/>
-          <a:p>
-            <a:pPr indent="0" marL="0">
-              <a:buNone/>
-            </a:pPr>
-            <a:r>
-              <a:rPr lang="en-US" sz="1800" dirty="0">
-                <a:solidFill>
-                  <a:srgbClr val="000000"/>
-                </a:solidFill>
-                <a:latin typeface="Calibri" pitchFamily="34" charset="0"/>
-                <a:ea typeface="Calibri" pitchFamily="34" charset="-122"/>
-                <a:cs typeface="Calibri" pitchFamily="34" charset="-120"/>
-              </a:rPr>
-              <a:t>✏️</a:t>
-            </a:r>
-            <a:endParaRPr lang="en-US" sz="1800" dirty="0"/>
+            <a:off x="7040880" y="3913632"/>
+            <a:ext cx="4572000" cy="292608"/>
+          </a:xfrm>
+          <a:prstGeom prst="rect">
+            <a:avLst/>
+          </a:prstGeom>
+          <a:noFill/>
+          <a:ln/>
+        </p:spPr>
+        <p:txBody>
+          <a:bodyPr wrap="square" rtlCol="0" anchor="ctr"/>
+          <a:lstStyle/>
+          <a:p>
+            <a:pPr indent="0" marL="0">
+              <a:buNone/>
+            </a:pPr>
+            <a:r>
+              <a:rPr lang="en-US" sz="1200" b="1" dirty="0">
+                <a:solidFill>
+                  <a:srgbClr val="0A1628"/>
+                </a:solidFill>
+                <a:latin typeface="Calibri" pitchFamily="34" charset="0"/>
+                <a:ea typeface="Calibri" pitchFamily="34" charset="-122"/>
+                <a:cs typeface="Calibri" pitchFamily="34" charset="-120"/>
+              </a:rPr>
+              <a:t>No silent rejections</a:t>
+            </a:r>
+            <a:endParaRPr lang="en-US" sz="1200" dirty="0"/>
           </a:p>
         </p:txBody>
       </p:sp>
@@ -22259,46 +22259,7 @@
         </p:nvSpPr>
         <p:spPr>
           <a:xfrm>
-            <a:off x="7040880" y="4690872"/>
-            <a:ext cx="4572000" cy="292608"/>
-          </a:xfrm>
-          <a:prstGeom prst="rect">
-            <a:avLst/>
-          </a:prstGeom>
-          <a:noFill/>
-          <a:ln/>
-        </p:spPr>
-        <p:txBody>
-          <a:bodyPr wrap="square" rtlCol="0" anchor="ctr"/>
-          <a:lstStyle/>
-          <a:p>
-            <a:pPr indent="0" marL="0">
-              <a:buNone/>
-            </a:pPr>
-            <a:r>
-              <a:rPr lang="en-US" sz="1200" b="1" dirty="0">
-                <a:solidFill>
-                  <a:srgbClr val="0A1628"/>
-                </a:solidFill>
-                <a:latin typeface="Calibri" pitchFamily="34" charset="0"/>
-                <a:ea typeface="Calibri" pitchFamily="34" charset="-122"/>
-                <a:cs typeface="Calibri" pitchFamily="34" charset="-120"/>
-              </a:rPr>
-              <a:t>Human-in-the-loop</a:t>
-            </a:r>
-            <a:endParaRPr lang="en-US" sz="1200" dirty="0"/>
-          </a:p>
-        </p:txBody>
-      </p:sp>
-      <p:sp>
-        <p:nvSpPr>
-          <p:cNvPr id="47" name="Text 45"/>
-          <p:cNvSpPr/>
-          <p:nvPr/>
-        </p:nvSpPr>
-        <p:spPr>
-          <a:xfrm>
-            <a:off x="7040880" y="4983480"/>
+            <a:off x="7040880" y="4206240"/>
             <a:ext cx="4572000" cy="274320"/>
           </a:xfrm>
           <a:prstGeom prst="rect">
@@ -22323,7 +22284,7 @@
                 <a:ea typeface="Calibri Light" pitchFamily="34" charset="-122"/>
                 <a:cs typeface="Calibri Light" pitchFamily="34" charset="-120"/>
               </a:rPr>
-              <a:t>Inline override with reason, captured to audit log.</a:t>
+              <a:t>Ambiguous values automatically routed to NEED_REVIEW.</a:t>
             </a:r>
             <a:endParaRPr lang="en-US" sz="1000" dirty="0"/>
           </a:p>
@@ -22331,13 +22292,13 @@
       </p:sp>
       <p:sp>
         <p:nvSpPr>
-          <p:cNvPr id="48" name="Shape 46"/>
-          <p:cNvSpPr/>
-          <p:nvPr/>
-        </p:nvSpPr>
-        <p:spPr>
-          <a:xfrm>
-            <a:off x="6400800" y="5394960"/>
+          <p:cNvPr id="47" name="Shape 45"/>
+          <p:cNvSpPr/>
+          <p:nvPr/>
+        </p:nvSpPr>
+        <p:spPr>
+          <a:xfrm>
+            <a:off x="6400800" y="4617720"/>
             <a:ext cx="5212080" cy="685800"/>
           </a:xfrm>
           <a:prstGeom prst="roundRect">
@@ -22358,40 +22319,79 @@
       </p:sp>
       <p:sp>
         <p:nvSpPr>
+          <p:cNvPr id="48" name="Text 46"/>
+          <p:cNvSpPr/>
+          <p:nvPr/>
+        </p:nvSpPr>
+        <p:spPr>
+          <a:xfrm>
+            <a:off x="6537960" y="4617720"/>
+            <a:ext cx="457200" cy="685800"/>
+          </a:xfrm>
+          <a:prstGeom prst="rect">
+            <a:avLst/>
+          </a:prstGeom>
+          <a:noFill/>
+          <a:ln/>
+        </p:spPr>
+        <p:txBody>
+          <a:bodyPr wrap="square" rtlCol="0" anchor="ctr"/>
+          <a:lstStyle/>
+          <a:p>
+            <a:pPr indent="0" marL="0">
+              <a:buNone/>
+            </a:pPr>
+            <a:r>
+              <a:rPr lang="en-US" sz="1800" dirty="0">
+                <a:solidFill>
+                  <a:srgbClr val="000000"/>
+                </a:solidFill>
+                <a:latin typeface="Calibri" pitchFamily="34" charset="0"/>
+                <a:ea typeface="Calibri" pitchFamily="34" charset="-122"/>
+                <a:cs typeface="Calibri" pitchFamily="34" charset="-120"/>
+              </a:rPr>
+              <a:t>✏️</a:t>
+            </a:r>
+            <a:endParaRPr lang="en-US" sz="1800" dirty="0"/>
+          </a:p>
+        </p:txBody>
+      </p:sp>
+      <p:sp>
+        <p:nvSpPr>
           <p:cNvPr id="49" name="Text 47"/>
           <p:cNvSpPr/>
           <p:nvPr/>
         </p:nvSpPr>
         <p:spPr>
           <a:xfrm>
-            <a:off x="6537960" y="5394960"/>
-            <a:ext cx="457200" cy="685800"/>
-          </a:xfrm>
-          <a:prstGeom prst="rect">
-            <a:avLst/>
-          </a:prstGeom>
-          <a:noFill/>
-          <a:ln/>
-        </p:spPr>
-        <p:txBody>
-          <a:bodyPr wrap="square" rtlCol="0" anchor="ctr"/>
-          <a:lstStyle/>
-          <a:p>
-            <a:pPr indent="0" marL="0">
-              <a:buNone/>
-            </a:pPr>
-            <a:r>
-              <a:rPr lang="en-US" sz="1800" dirty="0">
-                <a:solidFill>
-                  <a:srgbClr val="000000"/>
-                </a:solidFill>
-                <a:latin typeface="Calibri" pitchFamily="34" charset="0"/>
-                <a:ea typeface="Calibri" pitchFamily="34" charset="-122"/>
-                <a:cs typeface="Calibri" pitchFamily="34" charset="-120"/>
-              </a:rPr>
-              <a:t>📜</a:t>
-            </a:r>
-            <a:endParaRPr lang="en-US" sz="1800" dirty="0"/>
+            <a:off x="7040880" y="4690872"/>
+            <a:ext cx="4572000" cy="292608"/>
+          </a:xfrm>
+          <a:prstGeom prst="rect">
+            <a:avLst/>
+          </a:prstGeom>
+          <a:noFill/>
+          <a:ln/>
+        </p:spPr>
+        <p:txBody>
+          <a:bodyPr wrap="square" rtlCol="0" anchor="ctr"/>
+          <a:lstStyle/>
+          <a:p>
+            <a:pPr indent="0" marL="0">
+              <a:buNone/>
+            </a:pPr>
+            <a:r>
+              <a:rPr lang="en-US" sz="1200" b="1" dirty="0">
+                <a:solidFill>
+                  <a:srgbClr val="0A1628"/>
+                </a:solidFill>
+                <a:latin typeface="Calibri" pitchFamily="34" charset="0"/>
+                <a:ea typeface="Calibri" pitchFamily="34" charset="-122"/>
+                <a:cs typeface="Calibri" pitchFamily="34" charset="-120"/>
+              </a:rPr>
+              <a:t>Human-in-the-loop</a:t>
+            </a:r>
+            <a:endParaRPr lang="en-US" sz="1200" dirty="0"/>
           </a:p>
         </p:txBody>
       </p:sp>
@@ -22403,46 +22403,7 @@
         </p:nvSpPr>
         <p:spPr>
           <a:xfrm>
-            <a:off x="7040880" y="5468112"/>
-            <a:ext cx="4572000" cy="292608"/>
-          </a:xfrm>
-          <a:prstGeom prst="rect">
-            <a:avLst/>
-          </a:prstGeom>
-          <a:noFill/>
-          <a:ln/>
-        </p:spPr>
-        <p:txBody>
-          <a:bodyPr wrap="square" rtlCol="0" anchor="ctr"/>
-          <a:lstStyle/>
-          <a:p>
-            <a:pPr indent="0" marL="0">
-              <a:buNone/>
-            </a:pPr>
-            <a:r>
-              <a:rPr lang="en-US" sz="1200" b="1" dirty="0">
-                <a:solidFill>
-                  <a:srgbClr val="0A1628"/>
-                </a:solidFill>
-                <a:latin typeface="Calibri" pitchFamily="34" charset="0"/>
-                <a:ea typeface="Calibri" pitchFamily="34" charset="-122"/>
-                <a:cs typeface="Calibri" pitchFamily="34" charset="-120"/>
-              </a:rPr>
-              <a:t>Append-only audit log</a:t>
-            </a:r>
-            <a:endParaRPr lang="en-US" sz="1200" dirty="0"/>
-          </a:p>
-        </p:txBody>
-      </p:sp>
-      <p:sp>
-        <p:nvSpPr>
-          <p:cNvPr id="51" name="Text 49"/>
-          <p:cNvSpPr/>
-          <p:nvPr/>
-        </p:nvSpPr>
-        <p:spPr>
-          <a:xfrm>
-            <a:off x="7040880" y="5760720"/>
+            <a:off x="7040880" y="4983480"/>
             <a:ext cx="4572000" cy="274320"/>
           </a:xfrm>
           <a:prstGeom prst="rect">
@@ -22467,6 +22428,150 @@
                 <a:ea typeface="Calibri Light" pitchFamily="34" charset="-122"/>
                 <a:cs typeface="Calibri Light" pitchFamily="34" charset="-120"/>
               </a:rPr>
+              <a:t>Inline override with reason, captured to audit log.</a:t>
+            </a:r>
+            <a:endParaRPr lang="en-US" sz="1000" dirty="0"/>
+          </a:p>
+        </p:txBody>
+      </p:sp>
+      <p:sp>
+        <p:nvSpPr>
+          <p:cNvPr id="51" name="Shape 49"/>
+          <p:cNvSpPr/>
+          <p:nvPr/>
+        </p:nvSpPr>
+        <p:spPr>
+          <a:xfrm>
+            <a:off x="6400800" y="5394960"/>
+            <a:ext cx="5212080" cy="685800"/>
+          </a:xfrm>
+          <a:prstGeom prst="roundRect">
+            <a:avLst>
+              <a:gd name="adj" fmla="val 21333"/>
+            </a:avLst>
+          </a:prstGeom>
+          <a:solidFill>
+            <a:srgbClr val="FFFFFF"/>
+          </a:solidFill>
+          <a:ln w="12700">
+            <a:solidFill>
+              <a:srgbClr val="CBD5E1"/>
+            </a:solidFill>
+            <a:prstDash val="solid"/>
+          </a:ln>
+        </p:spPr>
+      </p:sp>
+      <p:sp>
+        <p:nvSpPr>
+          <p:cNvPr id="52" name="Text 50"/>
+          <p:cNvSpPr/>
+          <p:nvPr/>
+        </p:nvSpPr>
+        <p:spPr>
+          <a:xfrm>
+            <a:off x="6537960" y="5394960"/>
+            <a:ext cx="457200" cy="685800"/>
+          </a:xfrm>
+          <a:prstGeom prst="rect">
+            <a:avLst/>
+          </a:prstGeom>
+          <a:noFill/>
+          <a:ln/>
+        </p:spPr>
+        <p:txBody>
+          <a:bodyPr wrap="square" rtlCol="0" anchor="ctr"/>
+          <a:lstStyle/>
+          <a:p>
+            <a:pPr indent="0" marL="0">
+              <a:buNone/>
+            </a:pPr>
+            <a:r>
+              <a:rPr lang="en-US" sz="1800" dirty="0">
+                <a:solidFill>
+                  <a:srgbClr val="000000"/>
+                </a:solidFill>
+                <a:latin typeface="Calibri" pitchFamily="34" charset="0"/>
+                <a:ea typeface="Calibri" pitchFamily="34" charset="-122"/>
+                <a:cs typeface="Calibri" pitchFamily="34" charset="-120"/>
+              </a:rPr>
+              <a:t>📜</a:t>
+            </a:r>
+            <a:endParaRPr lang="en-US" sz="1800" dirty="0"/>
+          </a:p>
+        </p:txBody>
+      </p:sp>
+      <p:sp>
+        <p:nvSpPr>
+          <p:cNvPr id="53" name="Text 51"/>
+          <p:cNvSpPr/>
+          <p:nvPr/>
+        </p:nvSpPr>
+        <p:spPr>
+          <a:xfrm>
+            <a:off x="7040880" y="5468112"/>
+            <a:ext cx="4572000" cy="292608"/>
+          </a:xfrm>
+          <a:prstGeom prst="rect">
+            <a:avLst/>
+          </a:prstGeom>
+          <a:noFill/>
+          <a:ln/>
+        </p:spPr>
+        <p:txBody>
+          <a:bodyPr wrap="square" rtlCol="0" anchor="ctr"/>
+          <a:lstStyle/>
+          <a:p>
+            <a:pPr indent="0" marL="0">
+              <a:buNone/>
+            </a:pPr>
+            <a:r>
+              <a:rPr lang="en-US" sz="1200" b="1" dirty="0">
+                <a:solidFill>
+                  <a:srgbClr val="0A1628"/>
+                </a:solidFill>
+                <a:latin typeface="Calibri" pitchFamily="34" charset="0"/>
+                <a:ea typeface="Calibri" pitchFamily="34" charset="-122"/>
+                <a:cs typeface="Calibri" pitchFamily="34" charset="-120"/>
+              </a:rPr>
+              <a:t>Append-only audit log</a:t>
+            </a:r>
+            <a:endParaRPr lang="en-US" sz="1200" dirty="0"/>
+          </a:p>
+        </p:txBody>
+      </p:sp>
+      <p:sp>
+        <p:nvSpPr>
+          <p:cNvPr id="54" name="Text 52"/>
+          <p:cNvSpPr/>
+          <p:nvPr/>
+        </p:nvSpPr>
+        <p:spPr>
+          <a:xfrm>
+            <a:off x="7040880" y="5760720"/>
+            <a:ext cx="4572000" cy="274320"/>
+          </a:xfrm>
+          <a:prstGeom prst="rect">
+            <a:avLst/>
+          </a:prstGeom>
+          <a:noFill/>
+          <a:ln/>
+        </p:spPr>
+        <p:txBody>
+          <a:bodyPr wrap="square" rtlCol="0" anchor="ctr"/>
+          <a:lstStyle/>
+          <a:p>
+            <a:pPr indent="0" marL="0">
+              <a:buNone/>
+            </a:pPr>
+            <a:r>
+              <a:rPr lang="en-US" sz="1000" dirty="0">
+                <a:solidFill>
+                  <a:srgbClr val="475569"/>
+                </a:solidFill>
+                <a:latin typeface="Calibri Light" pitchFamily="34" charset="0"/>
+                <a:ea typeface="Calibri Light" pitchFamily="34" charset="-122"/>
+                <a:cs typeface="Calibri Light" pitchFamily="34" charset="-120"/>
+              </a:rPr>
               <a:t>Immutable JSONL of every action — automated or human.</a:t>
             </a:r>
             <a:endParaRPr lang="en-US" sz="1000" dirty="0"/>
@@ -22475,7 +22580,7 @@
       </p:sp>
       <p:sp>
         <p:nvSpPr>
-          <p:cNvPr id="52" name="Text 50"/>
+          <p:cNvPr id="55" name="Text 53"/>
           <p:cNvSpPr/>
           <p:nvPr/>
         </p:nvSpPr>
@@ -22641,7 +22746,7 @@
                 <a:ea typeface="Calibri" pitchFamily="34" charset="-122"/>
                 <a:cs typeface="Calibri" pitchFamily="34" charset="-120"/>
               </a:rPr>
-              <a:t>08 · INNOVATION</a:t>
+              <a:t>08 · INNOVATION · LAYER 4 OF THE AI STACK</a:t>
             </a:r>
             <a:endParaRPr lang="en-US" sz="1100" dirty="0"/>
           </a:p>

</xml_diff>